<commit_message>
Add "What It Can Do" demo segment to Core 1
Five real-task use cases (live data analysis with a fabricated crash
dataset, draft review, presentation outline, email triage, citation
check) added to the workshop page, HTML slides, PowerPoint, and
instructor guide. Timing adjusted to fit the hour.

Co-Authored-By: Claude Opus 5.5 <noreply@anthropic.com>
</commit_message>
<xml_diff>
--- a/docs/slides/DSPH_Workshop1_Foundations_and_Capabilities.pptx
+++ b/docs/slides/DSPH_Workshop1_Foundations_and_Capabilities.pptx
@@ -11,6 +11,12 @@
     <p:sldId id="259" r:id="rId5"/>
     <p:sldId id="260" r:id="rId6"/>
     <p:sldId id="261" r:id="rId7"/>
+    <p:sldId id="270" r:id="rId21"/>
+    <p:sldId id="271" r:id="rId22"/>
+    <p:sldId id="272" r:id="rId23"/>
+    <p:sldId id="273" r:id="rId24"/>
+    <p:sldId id="274" r:id="rId25"/>
+    <p:sldId id="275" r:id="rId26"/>
     <p:sldId id="262" r:id="rId8"/>
     <p:sldId id="263" r:id="rId9"/>
     <p:sldId id="264" r:id="rId10"/>
@@ -997,6 +1003,356 @@
 </p:notes>
 </file>
 
+<file path=ppt/notesSlides/notesSlide15.xml><?xml version="1.0" encoding="utf-8"?>
+<p:notes xmlns:a="http://schemas.openxmlformats.org/drawingml/2006/main" xmlns:p="http://schemas.openxmlformats.org/presentationml/2006/main" xmlns:r="http://schemas.openxmlformats.org/officeDocument/2006/relationships">
+  <p:cSld>
+    <p:spTree>
+      <p:nvGrpSpPr>
+        <p:cNvPr id="1" name=""/>
+        <p:cNvGrpSpPr/>
+        <p:nvPr/>
+      </p:nvGrpSpPr>
+      <p:grpSpPr>
+        <a:xfrm>
+          <a:off x="0" y="0"/>
+          <a:ext cx="0" cy="0"/>
+          <a:chOff x="0" y="0"/>
+          <a:chExt cx="0" cy="0"/>
+        </a:xfrm>
+      </p:grpSpPr>
+      <p:sp>
+        <p:nvSpPr>
+          <p:cNvPr id="2" name="Slide Image Placeholder 1"/>
+          <p:cNvSpPr>
+            <a:spLocks noGrp="1"/>
+          </p:cNvSpPr>
+          <p:nvPr>
+            <p:ph type="sldImg" idx="2"/>
+          </p:nvPr>
+        </p:nvSpPr>
+        <p:spPr/>
+      </p:sp>
+      <p:sp>
+        <p:nvSpPr>
+          <p:cNvPr id="3" name="Notes Placeholder 2"/>
+          <p:cNvSpPr>
+            <a:spLocks noGrp="1"/>
+          </p:cNvSpPr>
+          <p:nvPr>
+            <p:ph type="body" idx="3" sz="quarter"/>
+          </p:nvPr>
+        </p:nvSpPr>
+        <p:spPr/>
+        <p:txBody>
+          <a:bodyPr/>
+          <a:lstStyle/>
+          <a:p>
+            <a:r>
+              <a:t>Transition: before you try it, here is what it can do on work like ours. About 8 minutes; one live demo.</a:t>
+            </a:r>
+          </a:p>
+        </p:txBody>
+      </p:sp>
+      <p:sp>
+        <p:nvSpPr>
+          <p:cNvPr id="4" name="Slide Number Placeholder 3"/>
+          <p:cNvSpPr>
+            <a:spLocks noGrp="1"/>
+          </p:cNvSpPr>
+          <p:nvPr>
+            <p:ph type="sldNum" idx="5" sz="quarter"/>
+          </p:nvPr>
+        </p:nvSpPr>
+        <p:spPr/>
+      </p:sp>
+    </p:spTree>
+  </p:cSld>
+  <p:clrMapOvr>
+    <a:masterClrMapping/>
+  </p:clrMapOvr>
+</p:notes>
+</file>
+
+<file path=ppt/notesSlides/notesSlide16.xml><?xml version="1.0" encoding="utf-8"?>
+<p:notes xmlns:a="http://schemas.openxmlformats.org/drawingml/2006/main" xmlns:p="http://schemas.openxmlformats.org/presentationml/2006/main" xmlns:r="http://schemas.openxmlformats.org/officeDocument/2006/relationships">
+  <p:cSld>
+    <p:spTree>
+      <p:nvGrpSpPr>
+        <p:cNvPr id="1" name=""/>
+        <p:cNvGrpSpPr/>
+        <p:nvPr/>
+      </p:nvGrpSpPr>
+      <p:grpSpPr>
+        <a:xfrm>
+          <a:off x="0" y="0"/>
+          <a:ext cx="0" cy="0"/>
+          <a:chOff x="0" y="0"/>
+          <a:chExt cx="0" cy="0"/>
+        </a:xfrm>
+      </p:grpSpPr>
+      <p:sp>
+        <p:nvSpPr>
+          <p:cNvPr id="2" name="Slide Image Placeholder 1"/>
+          <p:cNvSpPr>
+            <a:spLocks noGrp="1"/>
+          </p:cNvSpPr>
+          <p:nvPr>
+            <p:ph type="sldImg" idx="2"/>
+          </p:nvPr>
+        </p:nvSpPr>
+        <p:spPr/>
+      </p:sp>
+      <p:sp>
+        <p:nvSpPr>
+          <p:cNvPr id="3" name="Notes Placeholder 2"/>
+          <p:cNvSpPr>
+            <a:spLocks noGrp="1"/>
+          </p:cNvSpPr>
+          <p:nvPr>
+            <p:ph type="body" idx="3" sz="quarter"/>
+          </p:nvPr>
+        </p:nvSpPr>
+        <p:spPr/>
+        <p:txBody>
+          <a:bodyPr/>
+          <a:lstStyle/>
+          <a:p>
+            <a:r>
+              <a:t>LIVE (~3 min). Upload demo-materials/Workshop1_Demo_RivertonPedCrashes.csv to ChatGPT Edu and paste the prompt on the slide. While it works: 'It is writing and running analysis code. You can click to see it.' Point to the flagged problems (6 missing speed limits, 3 rows with hour = 99). If it misses them, ask: 'Are there any missing or impossible values?' If the network fails, use this slide; it shows a real result from the same file.</a:t>
+            </a:r>
+          </a:p>
+        </p:txBody>
+      </p:sp>
+      <p:sp>
+        <p:nvSpPr>
+          <p:cNvPr id="4" name="Slide Number Placeholder 3"/>
+          <p:cNvSpPr>
+            <a:spLocks noGrp="1"/>
+          </p:cNvSpPr>
+          <p:nvPr>
+            <p:ph type="sldNum" idx="5" sz="quarter"/>
+          </p:nvPr>
+        </p:nvSpPr>
+        <p:spPr/>
+      </p:sp>
+    </p:spTree>
+  </p:cSld>
+  <p:clrMapOvr>
+    <a:masterClrMapping/>
+  </p:clrMapOvr>
+</p:notes>
+</file>
+
+<file path=ppt/notesSlides/notesSlide17.xml><?xml version="1.0" encoding="utf-8"?>
+<p:notes xmlns:a="http://schemas.openxmlformats.org/drawingml/2006/main" xmlns:p="http://schemas.openxmlformats.org/presentationml/2006/main" xmlns:r="http://schemas.openxmlformats.org/officeDocument/2006/relationships">
+  <p:cSld>
+    <p:spTree>
+      <p:nvGrpSpPr>
+        <p:cNvPr id="1" name=""/>
+        <p:cNvGrpSpPr/>
+        <p:nvPr/>
+      </p:nvGrpSpPr>
+      <p:grpSpPr>
+        <a:xfrm>
+          <a:off x="0" y="0"/>
+          <a:ext cx="0" cy="0"/>
+          <a:chOff x="0" y="0"/>
+          <a:chExt cx="0" cy="0"/>
+        </a:xfrm>
+      </p:grpSpPr>
+      <p:sp>
+        <p:nvSpPr>
+          <p:cNvPr id="2" name="Slide Image Placeholder 1"/>
+          <p:cNvSpPr>
+            <a:spLocks noGrp="1"/>
+          </p:cNvSpPr>
+          <p:nvPr>
+            <p:ph type="sldImg" idx="2"/>
+          </p:nvPr>
+        </p:nvSpPr>
+        <p:spPr/>
+      </p:sp>
+      <p:sp>
+        <p:nvSpPr>
+          <p:cNvPr id="3" name="Notes Placeholder 2"/>
+          <p:cNvSpPr>
+            <a:spLocks noGrp="1"/>
+          </p:cNvSpPr>
+          <p:nvPr>
+            <p:ph type="body" idx="3" sz="quarter"/>
+          </p:nvPr>
+        </p:nvSpPr>
+        <p:spPr/>
+        <p:txBody>
+          <a:bodyPr/>
+          <a:lstStyle/>
+          <a:p>
+            <a:r>
+              <a:t>~1 min. 'This is my draft, not the AI's. I ask it to act like a study section reviewer and to not rewrite anything.' The critique is real model output, trimmed. NIH will not review applications substantially developed by AI (NOT-OD-25-132). Use it to critique, not to write.</a:t>
+            </a:r>
+          </a:p>
+        </p:txBody>
+      </p:sp>
+      <p:sp>
+        <p:nvSpPr>
+          <p:cNvPr id="4" name="Slide Number Placeholder 3"/>
+          <p:cNvSpPr>
+            <a:spLocks noGrp="1"/>
+          </p:cNvSpPr>
+          <p:nvPr>
+            <p:ph type="sldNum" idx="5" sz="quarter"/>
+          </p:nvPr>
+        </p:nvSpPr>
+        <p:spPr/>
+      </p:sp>
+    </p:spTree>
+  </p:cSld>
+  <p:clrMapOvr>
+    <a:masterClrMapping/>
+  </p:clrMapOvr>
+</p:notes>
+</file>
+
+<file path=ppt/notesSlides/notesSlide18.xml><?xml version="1.0" encoding="utf-8"?>
+<p:notes xmlns:a="http://schemas.openxmlformats.org/drawingml/2006/main" xmlns:p="http://schemas.openxmlformats.org/presentationml/2006/main" xmlns:r="http://schemas.openxmlformats.org/officeDocument/2006/relationships">
+  <p:cSld>
+    <p:spTree>
+      <p:nvGrpSpPr>
+        <p:cNvPr id="1" name=""/>
+        <p:cNvGrpSpPr/>
+        <p:nvPr/>
+      </p:nvGrpSpPr>
+      <p:grpSpPr>
+        <a:xfrm>
+          <a:off x="0" y="0"/>
+          <a:ext cx="0" cy="0"/>
+          <a:chOff x="0" y="0"/>
+          <a:chExt cx="0" cy="0"/>
+        </a:xfrm>
+      </p:grpSpPr>
+      <p:sp>
+        <p:nvSpPr>
+          <p:cNvPr id="2" name="Slide Image Placeholder 1"/>
+          <p:cNvSpPr>
+            <a:spLocks noGrp="1"/>
+          </p:cNvSpPr>
+          <p:nvPr>
+            <p:ph type="sldImg" idx="2"/>
+          </p:nvPr>
+        </p:nvSpPr>
+        <p:spPr/>
+      </p:sp>
+      <p:sp>
+        <p:nvSpPr>
+          <p:cNvPr id="3" name="Notes Placeholder 2"/>
+          <p:cNvSpPr>
+            <a:spLocks noGrp="1"/>
+          </p:cNvSpPr>
+          <p:nvPr>
+            <p:ph type="body" idx="3" sz="quarter"/>
+          </p:nvPr>
+        </p:nvSpPr>
+        <p:spPr/>
+        <p:txBody>
+          <a:bodyPr/>
+          <a:lstStyle/>
+          <a:p>
+            <a:r>
+              <a:t>~1 min. The mini-slides are an example. ChatGPT Edu can produce a PowerPoint file directly. It also works for updating last year's deck with new numbers.</a:t>
+            </a:r>
+          </a:p>
+        </p:txBody>
+      </p:sp>
+      <p:sp>
+        <p:nvSpPr>
+          <p:cNvPr id="4" name="Slide Number Placeholder 3"/>
+          <p:cNvSpPr>
+            <a:spLocks noGrp="1"/>
+          </p:cNvSpPr>
+          <p:nvPr>
+            <p:ph type="sldNum" idx="5" sz="quarter"/>
+          </p:nvPr>
+        </p:nvSpPr>
+        <p:spPr/>
+      </p:sp>
+    </p:spTree>
+  </p:cSld>
+  <p:clrMapOvr>
+    <a:masterClrMapping/>
+  </p:clrMapOvr>
+</p:notes>
+</file>
+
+<file path=ppt/notesSlides/notesSlide19.xml><?xml version="1.0" encoding="utf-8"?>
+<p:notes xmlns:a="http://schemas.openxmlformats.org/drawingml/2006/main" xmlns:p="http://schemas.openxmlformats.org/presentationml/2006/main" xmlns:r="http://schemas.openxmlformats.org/officeDocument/2006/relationships">
+  <p:cSld>
+    <p:spTree>
+      <p:nvGrpSpPr>
+        <p:cNvPr id="1" name=""/>
+        <p:cNvGrpSpPr/>
+        <p:nvPr/>
+      </p:nvGrpSpPr>
+      <p:grpSpPr>
+        <a:xfrm>
+          <a:off x="0" y="0"/>
+          <a:ext cx="0" cy="0"/>
+          <a:chOff x="0" y="0"/>
+          <a:chExt cx="0" cy="0"/>
+        </a:xfrm>
+      </p:grpSpPr>
+      <p:sp>
+        <p:nvSpPr>
+          <p:cNvPr id="2" name="Slide Image Placeholder 1"/>
+          <p:cNvSpPr>
+            <a:spLocks noGrp="1"/>
+          </p:cNvSpPr>
+          <p:nvPr>
+            <p:ph type="sldImg" idx="2"/>
+          </p:nvPr>
+        </p:nvSpPr>
+        <p:spPr/>
+      </p:sp>
+      <p:sp>
+        <p:nvSpPr>
+          <p:cNvPr id="3" name="Notes Placeholder 2"/>
+          <p:cNvSpPr>
+            <a:spLocks noGrp="1"/>
+          </p:cNvSpPr>
+          <p:nvPr>
+            <p:ph type="body" idx="3" sz="quarter"/>
+          </p:nvPr>
+        </p:nvSpPr>
+        <p:spPr/>
+        <p:txBody>
+          <a:bodyPr/>
+          <a:lstStyle/>
+          <a:p>
+            <a:r>
+              <a:t>~1.5 min. Email triage is the easy win for staff. Citations: a model was asked for 5 LPI studies, gave 2, and declined to invent the rest. Fayish &amp; Gross 2010 (10.3141/2198-03) is correct. Van Houten et al. 2000: it gave 10.3141/1734-11, which resolves to a motorcycle helmet paper; correct is 10.3141/1734-13. 'Even a careful answer had a wrong citation.'</a:t>
+            </a:r>
+          </a:p>
+        </p:txBody>
+      </p:sp>
+      <p:sp>
+        <p:nvSpPr>
+          <p:cNvPr id="4" name="Slide Number Placeholder 3"/>
+          <p:cNvSpPr>
+            <a:spLocks noGrp="1"/>
+          </p:cNvSpPr>
+          <p:nvPr>
+            <p:ph type="sldNum" idx="5" sz="quarter"/>
+          </p:nvPr>
+        </p:nvSpPr>
+        <p:spPr/>
+      </p:sp>
+    </p:spTree>
+  </p:cSld>
+  <p:clrMapOvr>
+    <a:masterClrMapping/>
+  </p:clrMapOvr>
+</p:notes>
+</file>
+
 <file path=ppt/notesSlides/notesSlide2.xml><?xml version="1.0" encoding="utf-8"?>
 <p:notes xmlns:a="http://schemas.openxmlformats.org/drawingml/2006/main" xmlns:r="http://schemas.openxmlformats.org/officeDocument/2006/relationships" xmlns:p="http://schemas.openxmlformats.org/presentationml/2006/main">
   <p:cSld>
@@ -1078,6 +1434,76 @@
         <p14:creationId xmlns:p14="http://schemas.microsoft.com/office/powerpoint/2010/main" val="1024086991"/>
       </p:ext>
     </p:extLst>
+  </p:cSld>
+  <p:clrMapOvr>
+    <a:masterClrMapping/>
+  </p:clrMapOvr>
+</p:notes>
+</file>
+
+<file path=ppt/notesSlides/notesSlide20.xml><?xml version="1.0" encoding="utf-8"?>
+<p:notes xmlns:a="http://schemas.openxmlformats.org/drawingml/2006/main" xmlns:p="http://schemas.openxmlformats.org/presentationml/2006/main" xmlns:r="http://schemas.openxmlformats.org/officeDocument/2006/relationships">
+  <p:cSld>
+    <p:spTree>
+      <p:nvGrpSpPr>
+        <p:cNvPr id="1" name=""/>
+        <p:cNvGrpSpPr/>
+        <p:nvPr/>
+      </p:nvGrpSpPr>
+      <p:grpSpPr>
+        <a:xfrm>
+          <a:off x="0" y="0"/>
+          <a:ext cx="0" cy="0"/>
+          <a:chOff x="0" y="0"/>
+          <a:chExt cx="0" cy="0"/>
+        </a:xfrm>
+      </p:grpSpPr>
+      <p:sp>
+        <p:nvSpPr>
+          <p:cNvPr id="2" name="Slide Image Placeholder 1"/>
+          <p:cNvSpPr>
+            <a:spLocks noGrp="1"/>
+          </p:cNvSpPr>
+          <p:nvPr>
+            <p:ph type="sldImg" idx="2"/>
+          </p:nvPr>
+        </p:nvSpPr>
+        <p:spPr/>
+      </p:sp>
+      <p:sp>
+        <p:nvSpPr>
+          <p:cNvPr id="3" name="Notes Placeholder 2"/>
+          <p:cNvSpPr>
+            <a:spLocks noGrp="1"/>
+          </p:cNvSpPr>
+          <p:nvPr>
+            <p:ph type="body" idx="3" sz="quarter"/>
+          </p:nvPr>
+        </p:nvSpPr>
+        <p:spPr/>
+        <p:txBody>
+          <a:bodyPr/>
+          <a:lstStyle/>
+          <a:p>
+            <a:r>
+              <a:t>~1 min. This section was built by an agentic tool working in my OneDrive folder. Stress the label: not Drexel-supported, low-risk data only. Everyone starts with ChatGPT Edu today.</a:t>
+            </a:r>
+          </a:p>
+        </p:txBody>
+      </p:sp>
+      <p:sp>
+        <p:nvSpPr>
+          <p:cNvPr id="4" name="Slide Number Placeholder 3"/>
+          <p:cNvSpPr>
+            <a:spLocks noGrp="1"/>
+          </p:cNvSpPr>
+          <p:nvPr>
+            <p:ph type="sldNum" idx="5" sz="quarter"/>
+          </p:nvPr>
+        </p:nvSpPr>
+        <p:spPr/>
+      </p:sp>
+    </p:spTree>
   </p:cSld>
   <p:clrMapOvr>
     <a:masterClrMapping/>
@@ -3424,7 +3850,7 @@
                 <a:ea typeface="Futura" pitchFamily="34" charset="-122"/>
                 <a:cs typeface="Futura" pitchFamily="34" charset="-120"/>
               </a:rPr>
-              <a:t>ACTIVITY 1 · ~15 MIN</a:t>
+              <a:t>ACTIVITY 1 · ~11 MIN</a:t>
             </a:r>
             <a:endParaRPr lang="en-US" sz="1800" dirty="0"/>
           </a:p>
@@ -3488,6 +3914,10 @@
           </a:solidFill>
           <a:ln/>
         </p:spPr>
+        <p:txBody>
+          <a:bodyPr/>
+          <a:p/>
+        </p:txBody>
       </p:sp>
       <p:sp>
         <p:nvSpPr>
@@ -3511,6 +3941,10 @@
             <a:prstDash val="solid"/>
           </a:ln>
         </p:spPr>
+        <p:txBody>
+          <a:bodyPr/>
+          <a:p/>
+        </p:txBody>
       </p:sp>
       <p:sp>
         <p:nvSpPr>
@@ -3883,7 +4317,7 @@
                 <a:ea typeface="Futura" pitchFamily="34" charset="-122"/>
                 <a:cs typeface="Futura" pitchFamily="34" charset="-120"/>
               </a:rPr>
-              <a:t>ACTIVITY 2 · ~15 MIN</a:t>
+              <a:t>ACTIVITY 2 · ~11 MIN</a:t>
             </a:r>
             <a:endParaRPr lang="en-US" sz="1800" dirty="0"/>
           </a:p>
@@ -3947,6 +4381,10 @@
           </a:solidFill>
           <a:ln/>
         </p:spPr>
+        <p:txBody>
+          <a:bodyPr/>
+          <a:p/>
+        </p:txBody>
       </p:sp>
       <p:sp>
         <p:nvSpPr>
@@ -3970,6 +4408,10 @@
             <a:prstDash val="solid"/>
           </a:ln>
         </p:spPr>
+        <p:txBody>
+          <a:bodyPr/>
+          <a:p/>
+        </p:txBody>
       </p:sp>
       <p:sp>
         <p:nvSpPr>
@@ -4073,6 +4515,10 @@
             <a:prstDash val="solid"/>
           </a:ln>
         </p:spPr>
+        <p:txBody>
+          <a:bodyPr/>
+          <a:p/>
+        </p:txBody>
       </p:sp>
       <p:sp>
         <p:nvSpPr>
@@ -4093,6 +4539,10 @@
           </a:solidFill>
           <a:ln/>
         </p:spPr>
+        <p:txBody>
+          <a:bodyPr/>
+          <a:p/>
+        </p:txBody>
       </p:sp>
       <p:sp>
         <p:nvSpPr>
@@ -4343,6 +4793,10 @@
             <a:prstDash val="solid"/>
           </a:ln>
         </p:spPr>
+        <p:txBody>
+          <a:bodyPr/>
+          <a:p/>
+        </p:txBody>
       </p:sp>
       <p:sp>
         <p:nvSpPr>
@@ -4363,6 +4817,10 @@
           </a:solidFill>
           <a:ln/>
         </p:spPr>
+        <p:txBody>
+          <a:bodyPr/>
+          <a:p/>
+        </p:txBody>
       </p:sp>
       <p:sp>
         <p:nvSpPr>
@@ -5265,6 +5723,340 @@
 </p:sld>
 </file>
 
+<file path=ppt/slides/slide15.xml><?xml version="1.0" encoding="utf-8"?>
+<p:sld xmlns:a="http://schemas.openxmlformats.org/drawingml/2006/main" xmlns:p="http://schemas.openxmlformats.org/presentationml/2006/main" xmlns:r="http://schemas.openxmlformats.org/officeDocument/2006/relationships">
+  <p:cSld>
+    <p:bg>
+      <p:bgPr>
+        <a:solidFill>
+          <a:srgbClr val="07294D"/>
+        </a:solidFill>
+      </p:bgPr>
+    </p:bg>
+    <p:spTree>
+      <p:nvGrpSpPr>
+        <p:cNvPr id="1" name=""/>
+        <p:cNvGrpSpPr/>
+        <p:nvPr/>
+      </p:nvGrpSpPr>
+      <p:grpSpPr/>
+      <p:sp>
+        <p:nvSpPr>
+          <p:cNvPr id="2" name="Text 0"/>
+          <p:cNvSpPr txBox="1"/>
+          <p:nvPr/>
+        </p:nvSpPr>
+        <p:spPr>
+          <a:xfrm>
+            <a:off x="1028700" y="3383280"/>
+            <a:ext cx="16230600" cy="274320"/>
+          </a:xfrm>
+          <a:prstGeom prst="rect">
+            <a:avLst/>
+          </a:prstGeom>
+          <a:noFill/>
+          <a:ln/>
+        </p:spPr>
+        <p:txBody>
+          <a:bodyPr wrap="square" lIns="0" tIns="0" rIns="0" bIns="0" rtlCol="0" anchor="t"/>
+          <a:lstStyle/>
+          <a:p>
+            <a:pPr indent="0" marL="0">
+              <a:buNone/>
+            </a:pPr>
+            <a:r>
+              <a:rPr lang="en-US" sz="1800" b="1" spc="300" kern="0" dirty="0">
+                <a:solidFill>
+                  <a:srgbClr val="FFC600"/>
+                </a:solidFill>
+                <a:latin typeface="Futura" pitchFamily="34" charset="0"/>
+                <a:ea typeface="Futura" pitchFamily="34" charset="-122"/>
+                <a:cs typeface="Futura" pitchFamily="34" charset="-120"/>
+              </a:rPr>
+              <a:t>SECTION 02</a:t>
+            </a:r>
+            <a:endParaRPr lang="en-US" sz="1800" dirty="0"/>
+          </a:p>
+        </p:txBody>
+      </p:sp>
+      <p:sp>
+        <p:nvSpPr>
+          <p:cNvPr id="3" name="Text 1"/>
+          <p:cNvSpPr txBox="1"/>
+          <p:nvPr/>
+        </p:nvSpPr>
+        <p:spPr>
+          <a:xfrm>
+            <a:off x="1028700" y="3749040"/>
+            <a:ext cx="16230600" cy="1097280"/>
+          </a:xfrm>
+          <a:prstGeom prst="rect">
+            <a:avLst/>
+          </a:prstGeom>
+          <a:noFill/>
+          <a:ln/>
+        </p:spPr>
+        <p:txBody>
+          <a:bodyPr wrap="square" lIns="0" tIns="0" rIns="0" bIns="0" rtlCol="0" anchor="ctr"/>
+          <a:lstStyle/>
+          <a:p>
+            <a:pPr indent="0" marL="0">
+              <a:buNone/>
+            </a:pPr>
+            <a:r>
+              <a:rPr lang="en-US" sz="7400" b="1" dirty="0">
+                <a:solidFill>
+                  <a:srgbClr val="FFFFFF"/>
+                </a:solidFill>
+                <a:latin typeface="Georgia" pitchFamily="34" charset="0"/>
+                <a:ea typeface="Georgia" pitchFamily="34" charset="-122"/>
+                <a:cs typeface="Georgia" pitchFamily="34" charset="-120"/>
+              </a:rPr>
+              <a:t>What It Can Do</a:t>
+            </a:r>
+            <a:endParaRPr lang="en-US" sz="7400" dirty="0"/>
+          </a:p>
+        </p:txBody>
+      </p:sp>
+      <p:sp>
+        <p:nvSpPr>
+          <p:cNvPr id="4" name="Shape 2"/>
+          <p:cNvSpPr/>
+          <p:nvPr/>
+        </p:nvSpPr>
+        <p:spPr>
+          <a:xfrm>
+            <a:off x="1028700" y="5074920"/>
+            <a:ext cx="777240" cy="73152"/>
+          </a:xfrm>
+          <a:prstGeom prst="rect">
+            <a:avLst/>
+          </a:prstGeom>
+          <a:solidFill>
+            <a:srgbClr val="FFC600"/>
+          </a:solidFill>
+          <a:ln/>
+        </p:spPr>
+        <p:txBody>
+          <a:bodyPr/>
+          <a:p/>
+        </p:txBody>
+      </p:sp>
+      <p:sp>
+        <p:nvSpPr>
+          <p:cNvPr id="5" name="Text 3"/>
+          <p:cNvSpPr txBox="1"/>
+          <p:nvPr/>
+        </p:nvSpPr>
+        <p:spPr>
+          <a:xfrm>
+            <a:off x="1028700" y="5486400"/>
+            <a:ext cx="13258800" cy="914400"/>
+          </a:xfrm>
+          <a:prstGeom prst="rect">
+            <a:avLst/>
+          </a:prstGeom>
+          <a:noFill/>
+          <a:ln/>
+        </p:spPr>
+        <p:txBody>
+          <a:bodyPr wrap="square" lIns="0" tIns="0" rIns="0" bIns="0" rtlCol="0" anchor="t"/>
+          <a:lstStyle/>
+          <a:p>
+            <a:pPr indent="0" marL="0">
+              <a:buNone/>
+            </a:pPr>
+            <a:r>
+              <a:rPr lang="en-US" sz="2800" dirty="0">
+                <a:solidFill>
+                  <a:srgbClr val="C7D2DF"/>
+                </a:solidFill>
+                <a:latin typeface="Futura" pitchFamily="34" charset="0"/>
+                <a:ea typeface="Futura" pitchFamily="34" charset="-122"/>
+                <a:cs typeface="Futura" pitchFamily="34" charset="-120"/>
+              </a:rPr>
+              <a:t>Five real tasks from public health work: analyze data, review a draft, build slides, sort an inbox, find sources, and one look past the chat box.</a:t>
+            </a:r>
+            <a:endParaRPr lang="en-US" sz="2800" dirty="0"/>
+          </a:p>
+        </p:txBody>
+      </p:sp>
+    </p:spTree>
+  </p:cSld>
+  <p:clrMapOvr>
+    <a:masterClrMapping/>
+  </p:clrMapOvr>
+</p:sld>
+</file>
+
+<file path=ppt/slides/slide16.xml><?xml version="1.0" encoding="utf-8"?>
+<p:sld xmlns:a="http://schemas.openxmlformats.org/drawingml/2006/main" xmlns:p="http://schemas.openxmlformats.org/presentationml/2006/main" xmlns:r="http://schemas.openxmlformats.org/officeDocument/2006/relationships">
+  <p:cSld>
+    <p:spTree>
+      <p:nvGrpSpPr>
+        <p:cNvPr id="1" name=""/>
+        <p:cNvGrpSpPr/>
+        <p:nvPr/>
+      </p:nvGrpSpPr>
+      <p:grpSpPr/>
+      <p:pic>
+        <p:nvPicPr>
+          <p:cNvPr id="2" name="Picture 1" descr="hi8.png"/>
+          <p:cNvPicPr>
+            <a:picLocks noChangeAspect="1"/>
+          </p:cNvPicPr>
+          <p:nvPr/>
+        </p:nvPicPr>
+        <p:blipFill>
+          <a:blip r:embed="rId2"/>
+          <a:stretch>
+            <a:fillRect/>
+          </a:stretch>
+        </p:blipFill>
+        <p:spPr>
+          <a:xfrm>
+            <a:off x="0" y="0"/>
+            <a:ext cx="18288000" cy="10287000"/>
+          </a:xfrm>
+          <a:prstGeom prst="rect">
+            <a:avLst/>
+          </a:prstGeom>
+        </p:spPr>
+      </p:pic>
+    </p:spTree>
+  </p:cSld>
+  <p:clrMapOvr>
+    <a:masterClrMapping/>
+  </p:clrMapOvr>
+</p:sld>
+</file>
+
+<file path=ppt/slides/slide17.xml><?xml version="1.0" encoding="utf-8"?>
+<p:sld xmlns:a="http://schemas.openxmlformats.org/drawingml/2006/main" xmlns:p="http://schemas.openxmlformats.org/presentationml/2006/main" xmlns:r="http://schemas.openxmlformats.org/officeDocument/2006/relationships">
+  <p:cSld>
+    <p:spTree>
+      <p:nvGrpSpPr>
+        <p:cNvPr id="1" name=""/>
+        <p:cNvGrpSpPr/>
+        <p:nvPr/>
+      </p:nvGrpSpPr>
+      <p:grpSpPr/>
+      <p:pic>
+        <p:nvPicPr>
+          <p:cNvPr id="2" name="Picture 1" descr="hi9.png"/>
+          <p:cNvPicPr>
+            <a:picLocks noChangeAspect="1"/>
+          </p:cNvPicPr>
+          <p:nvPr/>
+        </p:nvPicPr>
+        <p:blipFill>
+          <a:blip r:embed="rId2"/>
+          <a:stretch>
+            <a:fillRect/>
+          </a:stretch>
+        </p:blipFill>
+        <p:spPr>
+          <a:xfrm>
+            <a:off x="0" y="0"/>
+            <a:ext cx="18288000" cy="10287000"/>
+          </a:xfrm>
+          <a:prstGeom prst="rect">
+            <a:avLst/>
+          </a:prstGeom>
+        </p:spPr>
+      </p:pic>
+    </p:spTree>
+  </p:cSld>
+  <p:clrMapOvr>
+    <a:masterClrMapping/>
+  </p:clrMapOvr>
+</p:sld>
+</file>
+
+<file path=ppt/slides/slide18.xml><?xml version="1.0" encoding="utf-8"?>
+<p:sld xmlns:a="http://schemas.openxmlformats.org/drawingml/2006/main" xmlns:p="http://schemas.openxmlformats.org/presentationml/2006/main" xmlns:r="http://schemas.openxmlformats.org/officeDocument/2006/relationships">
+  <p:cSld>
+    <p:spTree>
+      <p:nvGrpSpPr>
+        <p:cNvPr id="1" name=""/>
+        <p:cNvGrpSpPr/>
+        <p:nvPr/>
+      </p:nvGrpSpPr>
+      <p:grpSpPr/>
+      <p:pic>
+        <p:nvPicPr>
+          <p:cNvPr id="2" name="Picture 1" descr="hi10.png"/>
+          <p:cNvPicPr>
+            <a:picLocks noChangeAspect="1"/>
+          </p:cNvPicPr>
+          <p:nvPr/>
+        </p:nvPicPr>
+        <p:blipFill>
+          <a:blip r:embed="rId2"/>
+          <a:stretch>
+            <a:fillRect/>
+          </a:stretch>
+        </p:blipFill>
+        <p:spPr>
+          <a:xfrm>
+            <a:off x="0" y="0"/>
+            <a:ext cx="18288000" cy="10287000"/>
+          </a:xfrm>
+          <a:prstGeom prst="rect">
+            <a:avLst/>
+          </a:prstGeom>
+        </p:spPr>
+      </p:pic>
+    </p:spTree>
+  </p:cSld>
+  <p:clrMapOvr>
+    <a:masterClrMapping/>
+  </p:clrMapOvr>
+</p:sld>
+</file>
+
+<file path=ppt/slides/slide19.xml><?xml version="1.0" encoding="utf-8"?>
+<p:sld xmlns:a="http://schemas.openxmlformats.org/drawingml/2006/main" xmlns:p="http://schemas.openxmlformats.org/presentationml/2006/main" xmlns:r="http://schemas.openxmlformats.org/officeDocument/2006/relationships">
+  <p:cSld>
+    <p:spTree>
+      <p:nvGrpSpPr>
+        <p:cNvPr id="1" name=""/>
+        <p:cNvGrpSpPr/>
+        <p:nvPr/>
+      </p:nvGrpSpPr>
+      <p:grpSpPr/>
+      <p:pic>
+        <p:nvPicPr>
+          <p:cNvPr id="2" name="Picture 1" descr="hi11.png"/>
+          <p:cNvPicPr>
+            <a:picLocks noChangeAspect="1"/>
+          </p:cNvPicPr>
+          <p:nvPr/>
+        </p:nvPicPr>
+        <p:blipFill>
+          <a:blip r:embed="rId2"/>
+          <a:stretch>
+            <a:fillRect/>
+          </a:stretch>
+        </p:blipFill>
+        <p:spPr>
+          <a:xfrm>
+            <a:off x="0" y="0"/>
+            <a:ext cx="18288000" cy="10287000"/>
+          </a:xfrm>
+          <a:prstGeom prst="rect">
+            <a:avLst/>
+          </a:prstGeom>
+        </p:spPr>
+      </p:pic>
+    </p:spTree>
+  </p:cSld>
+  <p:clrMapOvr>
+    <a:masterClrMapping/>
+  </p:clrMapOvr>
+</p:sld>
+</file>
+
 <file path=ppt/slides/slide2.xml><?xml version="1.0" encoding="utf-8"?>
 <p:sld xmlns:a="http://schemas.openxmlformats.org/drawingml/2006/main" xmlns:r="http://schemas.openxmlformats.org/officeDocument/2006/relationships" xmlns:p="http://schemas.openxmlformats.org/presentationml/2006/main">
   <p:cSld name="Slide 2">
@@ -5880,6 +6672,48 @@
           </a:p>
         </p:txBody>
       </p:sp>
+    </p:spTree>
+  </p:cSld>
+  <p:clrMapOvr>
+    <a:masterClrMapping/>
+  </p:clrMapOvr>
+</p:sld>
+</file>
+
+<file path=ppt/slides/slide20.xml><?xml version="1.0" encoding="utf-8"?>
+<p:sld xmlns:a="http://schemas.openxmlformats.org/drawingml/2006/main" xmlns:p="http://schemas.openxmlformats.org/presentationml/2006/main" xmlns:r="http://schemas.openxmlformats.org/officeDocument/2006/relationships">
+  <p:cSld>
+    <p:spTree>
+      <p:nvGrpSpPr>
+        <p:cNvPr id="1" name=""/>
+        <p:cNvGrpSpPr/>
+        <p:nvPr/>
+      </p:nvGrpSpPr>
+      <p:grpSpPr/>
+      <p:pic>
+        <p:nvPicPr>
+          <p:cNvPr id="2" name="Picture 1" descr="hi12.png"/>
+          <p:cNvPicPr>
+            <a:picLocks noChangeAspect="1"/>
+          </p:cNvPicPr>
+          <p:nvPr/>
+        </p:nvPicPr>
+        <p:blipFill>
+          <a:blip r:embed="rId2"/>
+          <a:stretch>
+            <a:fillRect/>
+          </a:stretch>
+        </p:blipFill>
+        <p:spPr>
+          <a:xfrm>
+            <a:off x="0" y="0"/>
+            <a:ext cx="18288000" cy="10287000"/>
+          </a:xfrm>
+          <a:prstGeom prst="rect">
+            <a:avLst/>
+          </a:prstGeom>
+        </p:spPr>
+      </p:pic>
     </p:spTree>
   </p:cSld>
   <p:clrMapOvr>
@@ -7877,7 +8711,7 @@
                 <a:ea typeface="Futura" pitchFamily="34" charset="-122"/>
                 <a:cs typeface="Futura" pitchFamily="34" charset="-120"/>
               </a:rPr>
-              <a:t>SECTION 02</a:t>
+              <a:t>SECTION 03</a:t>
             </a:r>
             <a:endParaRPr lang="en-US" sz="1800" dirty="0"/>
           </a:p>
@@ -7941,6 +8775,10 @@
           </a:solidFill>
           <a:ln/>
         </p:spPr>
+        <p:txBody>
+          <a:bodyPr/>
+          <a:p/>
+        </p:txBody>
       </p:sp>
       <p:sp>
         <p:nvSpPr>
@@ -8655,7 +9493,7 @@
                 <a:ea typeface="Futura" pitchFamily="34" charset="-122"/>
                 <a:cs typeface="Futura" pitchFamily="34" charset="-120"/>
               </a:rPr>
-              <a:t>SECTION 03</a:t>
+              <a:t>SECTION 04</a:t>
             </a:r>
             <a:endParaRPr lang="en-US" sz="1800" dirty="0"/>
           </a:p>
@@ -8719,6 +9557,10 @@
           </a:solidFill>
           <a:ln/>
         </p:spPr>
+        <p:txBody>
+          <a:bodyPr/>
+          <a:p/>
+        </p:txBody>
       </p:sp>
       <p:sp>
         <p:nvSpPr>

</xml_diff>

<commit_message>
Add student-groups demo to Core 1
Sixth 'What It Can Do' task: forming balanced student groups from a
de-identified roster. Page, HTML slides, PowerPoint (21 slides),
instructor guide, and a fabricated 24-student roster. Groups on the
slide checked against all three rules. Adds the PowerPoint build script.

Co-Authored-By: Claude Opus 5.5 <noreply@anthropic.com>
</commit_message>
<xml_diff>
--- a/docs/slides/DSPH_Workshop1_Foundations_and_Capabilities.pptx
+++ b/docs/slides/DSPH_Workshop1_Foundations_and_Capabilities.pptx
@@ -16,6 +16,7 @@
     <p:sldId id="272" r:id="rId23"/>
     <p:sldId id="273" r:id="rId24"/>
     <p:sldId id="274" r:id="rId25"/>
+    <p:sldId id="276" r:id="rId27"/>
     <p:sldId id="275" r:id="rId26"/>
     <p:sldId id="262" r:id="rId8"/>
     <p:sldId id="263" r:id="rId9"/>
@@ -1487,6 +1488,76 @@
           <a:p>
             <a:r>
               <a:t>~1 min. This section was built by an agentic tool working in my OneDrive folder. Stress the label: not Drexel-supported, low-risk data only. Everyone starts with ChatGPT Edu today.</a:t>
+            </a:r>
+          </a:p>
+        </p:txBody>
+      </p:sp>
+      <p:sp>
+        <p:nvSpPr>
+          <p:cNvPr id="4" name="Slide Number Placeholder 3"/>
+          <p:cNvSpPr>
+            <a:spLocks noGrp="1"/>
+          </p:cNvSpPr>
+          <p:nvPr>
+            <p:ph type="sldNum" idx="5" sz="quarter"/>
+          </p:nvPr>
+        </p:nvSpPr>
+        <p:spPr/>
+      </p:sp>
+    </p:spTree>
+  </p:cSld>
+  <p:clrMapOvr>
+    <a:masterClrMapping/>
+  </p:clrMapOvr>
+</p:notes>
+</file>
+
+<file path=ppt/notesSlides/notesSlide21.xml><?xml version="1.0" encoding="utf-8"?>
+<p:notes xmlns:a="http://schemas.openxmlformats.org/drawingml/2006/main" xmlns:p="http://schemas.openxmlformats.org/presentationml/2006/main" xmlns:r="http://schemas.openxmlformats.org/officeDocument/2006/relationships">
+  <p:cSld>
+    <p:spTree>
+      <p:nvGrpSpPr>
+        <p:cNvPr id="1" name=""/>
+        <p:cNvGrpSpPr/>
+        <p:nvPr/>
+      </p:nvGrpSpPr>
+      <p:grpSpPr>
+        <a:xfrm>
+          <a:off x="0" y="0"/>
+          <a:ext cx="0" cy="0"/>
+          <a:chOff x="0" y="0"/>
+          <a:chExt cx="0" cy="0"/>
+        </a:xfrm>
+      </p:grpSpPr>
+      <p:sp>
+        <p:nvSpPr>
+          <p:cNvPr id="2" name="Slide Image Placeholder 1"/>
+          <p:cNvSpPr>
+            <a:spLocks noGrp="1"/>
+          </p:cNvSpPr>
+          <p:nvPr>
+            <p:ph type="sldImg" idx="2"/>
+          </p:nvPr>
+        </p:nvSpPr>
+        <p:spPr/>
+      </p:sp>
+      <p:sp>
+        <p:nvSpPr>
+          <p:cNvPr id="3" name="Notes Placeholder 2"/>
+          <p:cNvSpPr>
+            <a:spLocks noGrp="1"/>
+          </p:cNvSpPr>
+          <p:nvPr>
+            <p:ph type="body" idx="3" sz="quarter"/>
+          </p:nvPr>
+        </p:nvSpPr>
+        <p:spPr/>
+        <p:txBody>
+          <a:bodyPr/>
+          <a:lstStyle/>
+          <a:p>
+            <a:r>
+              <a:t>~1 min. 'Even in ChatGPT Edu, I don't upload names. I swap names for IDs in Excel, upload only what matters for grouping, and match the names back myself.' Point to 'check each rule' in the prompt and tell them to count anyway. Roster is fabricated (demo-materials/Workshop1_Demo_AnonymizedRoster.csv); the groups shown meet all three rules.</a:t>
             </a:r>
           </a:p>
         </p:txBody>
@@ -2877,6 +2948,1087 @@
 </file>
 
 <file path=ppt/slides/slide10.xml><?xml version="1.0" encoding="utf-8"?>
+<p:sld xmlns:a="http://schemas.openxmlformats.org/drawingml/2006/main" xmlns:p="http://schemas.openxmlformats.org/presentationml/2006/main" xmlns:r="http://schemas.openxmlformats.org/officeDocument/2006/relationships">
+  <p:cSld>
+    <p:spTree>
+      <p:nvGrpSpPr>
+        <p:cNvPr id="1" name=""/>
+        <p:cNvGrpSpPr/>
+        <p:nvPr/>
+      </p:nvGrpSpPr>
+      <p:grpSpPr/>
+      <p:pic>
+        <p:nvPicPr>
+          <p:cNvPr id="2" name="Picture 1" descr="hi10.png"/>
+          <p:cNvPicPr>
+            <a:picLocks noChangeAspect="1"/>
+          </p:cNvPicPr>
+          <p:nvPr/>
+        </p:nvPicPr>
+        <p:blipFill>
+          <a:blip r:embed="rId2"/>
+          <a:stretch>
+            <a:fillRect/>
+          </a:stretch>
+        </p:blipFill>
+        <p:spPr>
+          <a:xfrm>
+            <a:off x="0" y="0"/>
+            <a:ext cx="18288000" cy="10287000"/>
+          </a:xfrm>
+          <a:prstGeom prst="rect">
+            <a:avLst/>
+          </a:prstGeom>
+        </p:spPr>
+      </p:pic>
+    </p:spTree>
+  </p:cSld>
+  <p:clrMapOvr>
+    <a:masterClrMapping/>
+  </p:clrMapOvr>
+</p:sld>
+</file>
+
+<file path=ppt/slides/slide11.xml><?xml version="1.0" encoding="utf-8"?>
+<p:sld xmlns:a="http://schemas.openxmlformats.org/drawingml/2006/main" xmlns:p="http://schemas.openxmlformats.org/presentationml/2006/main" xmlns:r="http://schemas.openxmlformats.org/officeDocument/2006/relationships">
+  <p:cSld>
+    <p:spTree>
+      <p:nvGrpSpPr>
+        <p:cNvPr id="1" name=""/>
+        <p:cNvGrpSpPr/>
+        <p:nvPr/>
+      </p:nvGrpSpPr>
+      <p:grpSpPr/>
+      <p:pic>
+        <p:nvPicPr>
+          <p:cNvPr id="2" name="Picture 1" descr="hi11.png"/>
+          <p:cNvPicPr>
+            <a:picLocks noChangeAspect="1"/>
+          </p:cNvPicPr>
+          <p:nvPr/>
+        </p:nvPicPr>
+        <p:blipFill>
+          <a:blip r:embed="rId2"/>
+          <a:stretch>
+            <a:fillRect/>
+          </a:stretch>
+        </p:blipFill>
+        <p:spPr>
+          <a:xfrm>
+            <a:off x="0" y="0"/>
+            <a:ext cx="18288000" cy="10287000"/>
+          </a:xfrm>
+          <a:prstGeom prst="rect">
+            <a:avLst/>
+          </a:prstGeom>
+        </p:spPr>
+      </p:pic>
+    </p:spTree>
+  </p:cSld>
+  <p:clrMapOvr>
+    <a:masterClrMapping/>
+  </p:clrMapOvr>
+</p:sld>
+</file>
+
+<file path=ppt/slides/slide12.xml><?xml version="1.0" encoding="utf-8"?>
+<p:sld xmlns:a="http://schemas.openxmlformats.org/drawingml/2006/main" xmlns:p="http://schemas.openxmlformats.org/presentationml/2006/main" xmlns:r="http://schemas.openxmlformats.org/officeDocument/2006/relationships">
+  <p:cSld>
+    <p:spTree>
+      <p:nvGrpSpPr>
+        <p:cNvPr id="1" name=""/>
+        <p:cNvGrpSpPr/>
+        <p:nvPr/>
+      </p:nvGrpSpPr>
+      <p:grpSpPr/>
+      <p:pic>
+        <p:nvPicPr>
+          <p:cNvPr id="2" name="Picture 1" descr="hi12.png"/>
+          <p:cNvPicPr>
+            <a:picLocks noChangeAspect="1"/>
+          </p:cNvPicPr>
+          <p:nvPr/>
+        </p:nvPicPr>
+        <p:blipFill>
+          <a:blip r:embed="rId2"/>
+          <a:stretch>
+            <a:fillRect/>
+          </a:stretch>
+        </p:blipFill>
+        <p:spPr>
+          <a:xfrm>
+            <a:off x="0" y="0"/>
+            <a:ext cx="18288000" cy="10287000"/>
+          </a:xfrm>
+          <a:prstGeom prst="rect">
+            <a:avLst/>
+          </a:prstGeom>
+        </p:spPr>
+      </p:pic>
+    </p:spTree>
+  </p:cSld>
+  <p:clrMapOvr>
+    <a:masterClrMapping/>
+  </p:clrMapOvr>
+</p:sld>
+</file>
+
+<file path=ppt/slides/slide13.xml><?xml version="1.0" encoding="utf-8"?>
+<p:sld xmlns:a="http://schemas.openxmlformats.org/drawingml/2006/main" xmlns:r="http://schemas.openxmlformats.org/officeDocument/2006/relationships" xmlns:p="http://schemas.openxmlformats.org/presentationml/2006/main">
+  <p:cSld name="Slide 7">
+    <p:bg>
+      <p:bgPr>
+        <a:solidFill>
+          <a:srgbClr val="07294D"/>
+        </a:solidFill>
+      </p:bgPr>
+    </p:bg>
+    <p:spTree>
+      <p:nvGrpSpPr>
+        <p:cNvPr id="1" name=""/>
+        <p:cNvGrpSpPr/>
+        <p:nvPr/>
+      </p:nvGrpSpPr>
+      <p:grpSpPr>
+        <a:xfrm>
+          <a:off x="0" y="0"/>
+          <a:ext cx="0" cy="0"/>
+          <a:chOff x="0" y="0"/>
+          <a:chExt cx="0" cy="0"/>
+        </a:xfrm>
+      </p:grpSpPr>
+      <p:sp>
+        <p:nvSpPr>
+          <p:cNvPr id="2" name="Text 0"/>
+          <p:cNvSpPr txBox="1"/>
+          <p:nvPr/>
+        </p:nvSpPr>
+        <p:spPr>
+          <a:xfrm>
+            <a:off x="1028700" y="3383280"/>
+            <a:ext cx="16230600" cy="274320"/>
+          </a:xfrm>
+          <a:prstGeom prst="rect">
+            <a:avLst/>
+          </a:prstGeom>
+          <a:noFill/>
+          <a:ln/>
+        </p:spPr>
+        <p:txBody>
+          <a:bodyPr wrap="square" lIns="0" tIns="0" rIns="0" bIns="0" rtlCol="0" anchor="t"/>
+          <a:lstStyle/>
+          <a:p>
+            <a:pPr indent="0" marL="0">
+              <a:buNone/>
+            </a:pPr>
+            <a:r>
+              <a:rPr lang="en-US" sz="1800" b="1" spc="300" kern="0" dirty="0">
+                <a:solidFill>
+                  <a:srgbClr val="FFC600"/>
+                </a:solidFill>
+                <a:latin typeface="Futura" pitchFamily="34" charset="0"/>
+                <a:ea typeface="Futura" pitchFamily="34" charset="-122"/>
+                <a:cs typeface="Futura" pitchFamily="34" charset="-120"/>
+              </a:rPr>
+              <a:t>SECTION 03</a:t>
+            </a:r>
+            <a:endParaRPr lang="en-US" sz="1800" dirty="0"/>
+          </a:p>
+        </p:txBody>
+      </p:sp>
+      <p:sp>
+        <p:nvSpPr>
+          <p:cNvPr id="3" name="Text 1"/>
+          <p:cNvSpPr txBox="1"/>
+          <p:nvPr/>
+        </p:nvSpPr>
+        <p:spPr>
+          <a:xfrm>
+            <a:off x="1028700" y="3749040"/>
+            <a:ext cx="16230600" cy="1097280"/>
+          </a:xfrm>
+          <a:prstGeom prst="rect">
+            <a:avLst/>
+          </a:prstGeom>
+          <a:noFill/>
+          <a:ln/>
+        </p:spPr>
+        <p:txBody>
+          <a:bodyPr wrap="square" lIns="0" tIns="0" rIns="0" bIns="0" rtlCol="0" anchor="ctr"/>
+          <a:lstStyle/>
+          <a:p>
+            <a:pPr indent="0" marL="0">
+              <a:buNone/>
+            </a:pPr>
+            <a:r>
+              <a:rPr lang="en-US" sz="7400" b="1" dirty="0">
+                <a:solidFill>
+                  <a:srgbClr val="FFFFFF"/>
+                </a:solidFill>
+                <a:latin typeface="Georgia" pitchFamily="34" charset="0"/>
+                <a:ea typeface="Georgia" pitchFamily="34" charset="-122"/>
+                <a:cs typeface="Georgia" pitchFamily="34" charset="-120"/>
+              </a:rPr>
+              <a:t>How AI Gets Things Wrong</a:t>
+            </a:r>
+            <a:endParaRPr lang="en-US" sz="7400" dirty="0"/>
+          </a:p>
+        </p:txBody>
+      </p:sp>
+      <p:sp>
+        <p:nvSpPr>
+          <p:cNvPr id="4" name="Shape 2"/>
+          <p:cNvSpPr/>
+          <p:nvPr/>
+        </p:nvSpPr>
+        <p:spPr>
+          <a:xfrm>
+            <a:off x="1028700" y="5074920"/>
+            <a:ext cx="777240" cy="73152"/>
+          </a:xfrm>
+          <a:prstGeom prst="rect">
+            <a:avLst/>
+          </a:prstGeom>
+          <a:solidFill>
+            <a:srgbClr val="FFC600"/>
+          </a:solidFill>
+          <a:ln/>
+        </p:spPr>
+        <p:txBody>
+          <a:bodyPr/>
+          <a:p/>
+        </p:txBody>
+      </p:sp>
+      <p:sp>
+        <p:nvSpPr>
+          <p:cNvPr id="5" name="Text 3"/>
+          <p:cNvSpPr txBox="1"/>
+          <p:nvPr/>
+        </p:nvSpPr>
+        <p:spPr>
+          <a:xfrm>
+            <a:off x="1028700" y="5486400"/>
+            <a:ext cx="13258800" cy="914400"/>
+          </a:xfrm>
+          <a:prstGeom prst="rect">
+            <a:avLst/>
+          </a:prstGeom>
+          <a:noFill/>
+          <a:ln/>
+        </p:spPr>
+        <p:txBody>
+          <a:bodyPr wrap="square" lIns="0" tIns="0" rIns="0" bIns="0" rtlCol="0" anchor="t"/>
+          <a:lstStyle/>
+          <a:p>
+            <a:pPr indent="0" marL="0">
+              <a:buNone/>
+            </a:pPr>
+            <a:r>
+              <a:rPr lang="en-US" sz="2800" dirty="0">
+                <a:solidFill>
+                  <a:srgbClr val="C7D2DF"/>
+                </a:solidFill>
+                <a:latin typeface="Futura" pitchFamily="34" charset="0"/>
+                <a:ea typeface="Futura" pitchFamily="34" charset="-122"/>
+                <a:cs typeface="Futura" pitchFamily="34" charset="-120"/>
+              </a:rPr>
+              <a:t>And who is responsible when it does.</a:t>
+            </a:r>
+            <a:endParaRPr lang="en-US" sz="2800" dirty="0"/>
+          </a:p>
+        </p:txBody>
+      </p:sp>
+    </p:spTree>
+  </p:cSld>
+  <p:clrMapOvr>
+    <a:masterClrMapping/>
+  </p:clrMapOvr>
+</p:sld>
+</file>
+
+<file path=ppt/slides/slide14.xml><?xml version="1.0" encoding="utf-8"?>
+<p:sld xmlns:a="http://schemas.openxmlformats.org/drawingml/2006/main" xmlns:r="http://schemas.openxmlformats.org/officeDocument/2006/relationships" xmlns:p="http://schemas.openxmlformats.org/presentationml/2006/main">
+  <p:cSld name="Slide 8">
+    <p:bg>
+      <p:bgPr>
+        <a:solidFill>
+          <a:srgbClr val="FFFFFF"/>
+        </a:solidFill>
+      </p:bgPr>
+    </p:bg>
+    <p:spTree>
+      <p:nvGrpSpPr>
+        <p:cNvPr id="1" name=""/>
+        <p:cNvGrpSpPr/>
+        <p:nvPr/>
+      </p:nvGrpSpPr>
+      <p:grpSpPr>
+        <a:xfrm>
+          <a:off x="0" y="0"/>
+          <a:ext cx="0" cy="0"/>
+          <a:chOff x="0" y="0"/>
+          <a:chExt cx="0" cy="0"/>
+        </a:xfrm>
+      </p:grpSpPr>
+      <p:sp>
+        <p:nvSpPr>
+          <p:cNvPr id="2" name="Text 0"/>
+          <p:cNvSpPr txBox="1"/>
+          <p:nvPr/>
+        </p:nvSpPr>
+        <p:spPr>
+          <a:xfrm>
+            <a:off x="1028700" y="868680"/>
+            <a:ext cx="16230600" cy="274320"/>
+          </a:xfrm>
+          <a:prstGeom prst="rect">
+            <a:avLst/>
+          </a:prstGeom>
+          <a:noFill/>
+          <a:ln/>
+        </p:spPr>
+        <p:txBody>
+          <a:bodyPr wrap="square" lIns="0" tIns="0" rIns="0" bIns="0" rtlCol="0" anchor="t"/>
+          <a:lstStyle/>
+          <a:p>
+            <a:pPr indent="0" marL="0">
+              <a:buNone/>
+            </a:pPr>
+            <a:r>
+              <a:rPr lang="en-US" sz="1800" b="1" spc="300" kern="0" dirty="0">
+                <a:solidFill>
+                  <a:srgbClr val="006699"/>
+                </a:solidFill>
+                <a:latin typeface="Futura" pitchFamily="34" charset="0"/>
+                <a:ea typeface="Futura" pitchFamily="34" charset="-122"/>
+                <a:cs typeface="Futura" pitchFamily="34" charset="-120"/>
+              </a:rPr>
+              <a:t>THREE THINGS TO REMEMBER</a:t>
+            </a:r>
+            <a:endParaRPr lang="en-US" sz="1800" dirty="0"/>
+          </a:p>
+        </p:txBody>
+      </p:sp>
+      <p:sp>
+        <p:nvSpPr>
+          <p:cNvPr id="3" name="Text 1"/>
+          <p:cNvSpPr txBox="1"/>
+          <p:nvPr/>
+        </p:nvSpPr>
+        <p:spPr>
+          <a:xfrm>
+            <a:off x="1028700" y="1188720"/>
+            <a:ext cx="16230600" cy="822960"/>
+          </a:xfrm>
+          <a:prstGeom prst="rect">
+            <a:avLst/>
+          </a:prstGeom>
+          <a:noFill/>
+          <a:ln/>
+        </p:spPr>
+        <p:txBody>
+          <a:bodyPr wrap="square" lIns="0" tIns="0" rIns="0" bIns="0" rtlCol="0" anchor="ctr"/>
+          <a:lstStyle/>
+          <a:p>
+            <a:pPr indent="0" marL="0">
+              <a:buNone/>
+            </a:pPr>
+            <a:r>
+              <a:rPr lang="en-US" sz="5500" b="1" dirty="0">
+                <a:solidFill>
+                  <a:srgbClr val="07294D"/>
+                </a:solidFill>
+                <a:latin typeface="Georgia" pitchFamily="34" charset="0"/>
+                <a:ea typeface="Georgia" pitchFamily="34" charset="-122"/>
+                <a:cs typeface="Georgia" pitchFamily="34" charset="-120"/>
+              </a:rPr>
+              <a:t>Wrong, Biased, and Yours</a:t>
+            </a:r>
+            <a:endParaRPr lang="en-US" sz="5500" dirty="0"/>
+          </a:p>
+        </p:txBody>
+      </p:sp>
+      <p:sp>
+        <p:nvSpPr>
+          <p:cNvPr id="4" name="Shape 2"/>
+          <p:cNvSpPr/>
+          <p:nvPr/>
+        </p:nvSpPr>
+        <p:spPr>
+          <a:xfrm>
+            <a:off x="1028700" y="2103120"/>
+            <a:ext cx="777240" cy="73152"/>
+          </a:xfrm>
+          <a:prstGeom prst="rect">
+            <a:avLst/>
+          </a:prstGeom>
+          <a:solidFill>
+            <a:srgbClr val="FFC600"/>
+          </a:solidFill>
+          <a:ln/>
+        </p:spPr>
+      </p:sp>
+      <p:sp>
+        <p:nvSpPr>
+          <p:cNvPr id="5" name="Shape 3"/>
+          <p:cNvSpPr/>
+          <p:nvPr/>
+        </p:nvSpPr>
+        <p:spPr>
+          <a:xfrm>
+            <a:off x="1028700" y="9646920"/>
+            <a:ext cx="16230600" cy="0"/>
+          </a:xfrm>
+          <a:prstGeom prst="line">
+            <a:avLst/>
+          </a:prstGeom>
+          <a:noFill/>
+          <a:ln w="9525">
+            <a:solidFill>
+              <a:srgbClr val="D0D3D4"/>
+            </a:solidFill>
+            <a:prstDash val="solid"/>
+          </a:ln>
+        </p:spPr>
+      </p:sp>
+      <p:sp>
+        <p:nvSpPr>
+          <p:cNvPr id="6" name="Text 4"/>
+          <p:cNvSpPr txBox="1"/>
+          <p:nvPr/>
+        </p:nvSpPr>
+        <p:spPr>
+          <a:xfrm>
+            <a:off x="1028700" y="9784080"/>
+            <a:ext cx="7315200" cy="274320"/>
+          </a:xfrm>
+          <a:prstGeom prst="rect">
+            <a:avLst/>
+          </a:prstGeom>
+          <a:noFill/>
+          <a:ln/>
+        </p:spPr>
+        <p:txBody>
+          <a:bodyPr wrap="square" lIns="0" tIns="0" rIns="0" bIns="0" rtlCol="0" anchor="t"/>
+          <a:lstStyle/>
+          <a:p>
+            <a:pPr indent="0" marL="0">
+              <a:buNone/>
+            </a:pPr>
+            <a:r>
+              <a:rPr lang="en-US" sz="1400" b="1" dirty="0">
+                <a:solidFill>
+                  <a:srgbClr val="07294D"/>
+                </a:solidFill>
+                <a:latin typeface="Futura" pitchFamily="34" charset="0"/>
+                <a:ea typeface="Futura" pitchFamily="34" charset="-122"/>
+                <a:cs typeface="Futura" pitchFamily="34" charset="-120"/>
+              </a:rPr>
+              <a:t>Environmental &amp; Occupational Health</a:t>
+            </a:r>
+            <a:endParaRPr lang="en-US" sz="1400" dirty="0"/>
+          </a:p>
+        </p:txBody>
+      </p:sp>
+      <p:sp>
+        <p:nvSpPr>
+          <p:cNvPr id="7" name="Text 5"/>
+          <p:cNvSpPr txBox="1"/>
+          <p:nvPr/>
+        </p:nvSpPr>
+        <p:spPr>
+          <a:xfrm>
+            <a:off x="9944100" y="9784080"/>
+            <a:ext cx="7315200" cy="274320"/>
+          </a:xfrm>
+          <a:prstGeom prst="rect">
+            <a:avLst/>
+          </a:prstGeom>
+          <a:noFill/>
+          <a:ln/>
+        </p:spPr>
+        <p:txBody>
+          <a:bodyPr wrap="square" lIns="0" tIns="0" rIns="0" bIns="0" rtlCol="0" anchor="t"/>
+          <a:lstStyle/>
+          <a:p>
+            <a:pPr algn="r" indent="0" marL="0">
+              <a:buNone/>
+            </a:pPr>
+            <a:r>
+              <a:rPr lang="en-US" sz="1400" dirty="0">
+                <a:solidFill>
+                  <a:srgbClr val="5A6571"/>
+                </a:solidFill>
+                <a:latin typeface="Futura" pitchFamily="34" charset="0"/>
+                <a:ea typeface="Futura" pitchFamily="34" charset="-122"/>
+                <a:cs typeface="Futura" pitchFamily="34" charset="-120"/>
+              </a:rPr>
+              <a:t>Dornsife School of Public Health</a:t>
+            </a:r>
+            <a:endParaRPr lang="en-US" sz="1400" dirty="0"/>
+          </a:p>
+        </p:txBody>
+      </p:sp>
+      <p:sp>
+        <p:nvSpPr>
+          <p:cNvPr id="9" name="Shape 6"/>
+          <p:cNvSpPr/>
+          <p:nvPr/>
+        </p:nvSpPr>
+        <p:spPr>
+          <a:xfrm>
+            <a:off x="1028700" y="2697480"/>
+            <a:ext cx="5029200" cy="4206240"/>
+          </a:xfrm>
+          <a:prstGeom prst="rect">
+            <a:avLst/>
+          </a:prstGeom>
+          <a:solidFill>
+            <a:srgbClr val="FFFFFF"/>
+          </a:solidFill>
+          <a:ln w="9525">
+            <a:solidFill>
+              <a:srgbClr val="D0D3D4"/>
+            </a:solidFill>
+            <a:prstDash val="solid"/>
+          </a:ln>
+        </p:spPr>
+      </p:sp>
+      <p:sp>
+        <p:nvSpPr>
+          <p:cNvPr id="10" name="Shape 7"/>
+          <p:cNvSpPr/>
+          <p:nvPr/>
+        </p:nvSpPr>
+        <p:spPr>
+          <a:xfrm>
+            <a:off x="1028700" y="2697480"/>
+            <a:ext cx="5029200" cy="91440"/>
+          </a:xfrm>
+          <a:prstGeom prst="rect">
+            <a:avLst/>
+          </a:prstGeom>
+          <a:solidFill>
+            <a:srgbClr val="07294D"/>
+          </a:solidFill>
+          <a:ln/>
+        </p:spPr>
+      </p:sp>
+      <p:sp>
+        <p:nvSpPr>
+          <p:cNvPr id="11" name="Text 8"/>
+          <p:cNvSpPr txBox="1"/>
+          <p:nvPr/>
+        </p:nvSpPr>
+        <p:spPr>
+          <a:xfrm>
+            <a:off x="1394460" y="3108960"/>
+            <a:ext cx="4297680" cy="548640"/>
+          </a:xfrm>
+          <a:prstGeom prst="rect">
+            <a:avLst/>
+          </a:prstGeom>
+          <a:noFill/>
+          <a:ln/>
+        </p:spPr>
+        <p:txBody>
+          <a:bodyPr wrap="square" lIns="0" tIns="0" rIns="0" bIns="0" rtlCol="0" anchor="t"/>
+          <a:lstStyle/>
+          <a:p>
+            <a:pPr indent="0" marL="0">
+              <a:buNone/>
+            </a:pPr>
+            <a:r>
+              <a:rPr lang="en-US" sz="3100" b="1" dirty="0">
+                <a:solidFill>
+                  <a:srgbClr val="07294D"/>
+                </a:solidFill>
+                <a:latin typeface="Georgia" pitchFamily="34" charset="0"/>
+                <a:ea typeface="Georgia" pitchFamily="34" charset="-122"/>
+                <a:cs typeface="Georgia" pitchFamily="34" charset="-120"/>
+              </a:rPr>
+              <a:t>It Makes Things Up</a:t>
+            </a:r>
+            <a:endParaRPr lang="en-US" sz="3100" dirty="0"/>
+          </a:p>
+        </p:txBody>
+      </p:sp>
+      <p:sp>
+        <p:nvSpPr>
+          <p:cNvPr id="12" name="Text 9"/>
+          <p:cNvSpPr txBox="1"/>
+          <p:nvPr/>
+        </p:nvSpPr>
+        <p:spPr>
+          <a:xfrm>
+            <a:off x="1394460" y="3840480"/>
+            <a:ext cx="4297680" cy="2743200"/>
+          </a:xfrm>
+          <a:prstGeom prst="rect">
+            <a:avLst/>
+          </a:prstGeom>
+          <a:noFill/>
+          <a:ln/>
+        </p:spPr>
+        <p:txBody>
+          <a:bodyPr wrap="square" lIns="0" tIns="0" rIns="0" bIns="0" rtlCol="0" anchor="t"/>
+          <a:lstStyle/>
+          <a:p>
+            <a:pPr indent="0" marL="0">
+              <a:lnSpc>
+                <a:spcPct val="125000"/>
+              </a:lnSpc>
+              <a:buNone/>
+            </a:pPr>
+            <a:r>
+              <a:rPr lang="en-US" sz="2300" dirty="0">
+                <a:solidFill>
+                  <a:srgbClr val="5A6571"/>
+                </a:solidFill>
+                <a:latin typeface="Futura" pitchFamily="34" charset="0"/>
+                <a:ea typeface="Futura" pitchFamily="34" charset="-122"/>
+                <a:cs typeface="Futura" pitchFamily="34" charset="-120"/>
+              </a:rPr>
+              <a:t>It predicts likely-sounding text, so it can invent facts, numbers, and citations. Check anything that matters.</a:t>
+            </a:r>
+            <a:endParaRPr lang="en-US" sz="2300" dirty="0"/>
+          </a:p>
+        </p:txBody>
+      </p:sp>
+      <p:sp>
+        <p:nvSpPr>
+          <p:cNvPr id="13" name="Shape 10"/>
+          <p:cNvSpPr/>
+          <p:nvPr/>
+        </p:nvSpPr>
+        <p:spPr>
+          <a:xfrm>
+            <a:off x="6629400" y="2697480"/>
+            <a:ext cx="5029200" cy="4206240"/>
+          </a:xfrm>
+          <a:prstGeom prst="rect">
+            <a:avLst/>
+          </a:prstGeom>
+          <a:solidFill>
+            <a:srgbClr val="FFFFFF"/>
+          </a:solidFill>
+          <a:ln w="9525">
+            <a:solidFill>
+              <a:srgbClr val="D0D3D4"/>
+            </a:solidFill>
+            <a:prstDash val="solid"/>
+          </a:ln>
+        </p:spPr>
+      </p:sp>
+      <p:sp>
+        <p:nvSpPr>
+          <p:cNvPr id="14" name="Shape 11"/>
+          <p:cNvSpPr/>
+          <p:nvPr/>
+        </p:nvSpPr>
+        <p:spPr>
+          <a:xfrm>
+            <a:off x="6629400" y="2697480"/>
+            <a:ext cx="5029200" cy="91440"/>
+          </a:xfrm>
+          <a:prstGeom prst="rect">
+            <a:avLst/>
+          </a:prstGeom>
+          <a:solidFill>
+            <a:srgbClr val="006699"/>
+          </a:solidFill>
+          <a:ln/>
+        </p:spPr>
+      </p:sp>
+      <p:sp>
+        <p:nvSpPr>
+          <p:cNvPr id="15" name="Text 12"/>
+          <p:cNvSpPr txBox="1"/>
+          <p:nvPr/>
+        </p:nvSpPr>
+        <p:spPr>
+          <a:xfrm>
+            <a:off x="6995160" y="3108960"/>
+            <a:ext cx="4297680" cy="548640"/>
+          </a:xfrm>
+          <a:prstGeom prst="rect">
+            <a:avLst/>
+          </a:prstGeom>
+          <a:noFill/>
+          <a:ln/>
+        </p:spPr>
+        <p:txBody>
+          <a:bodyPr wrap="square" lIns="0" tIns="0" rIns="0" bIns="0" rtlCol="0" anchor="t"/>
+          <a:lstStyle/>
+          <a:p>
+            <a:pPr indent="0" marL="0">
+              <a:buNone/>
+            </a:pPr>
+            <a:r>
+              <a:rPr lang="en-US" sz="3100" b="1" dirty="0">
+                <a:solidFill>
+                  <a:srgbClr val="07294D"/>
+                </a:solidFill>
+                <a:latin typeface="Georgia" pitchFamily="34" charset="0"/>
+                <a:ea typeface="Georgia" pitchFamily="34" charset="-122"/>
+                <a:cs typeface="Georgia" pitchFamily="34" charset="-120"/>
+              </a:rPr>
+              <a:t>It Can Be Biased</a:t>
+            </a:r>
+            <a:endParaRPr lang="en-US" sz="3100" dirty="0"/>
+          </a:p>
+        </p:txBody>
+      </p:sp>
+      <p:sp>
+        <p:nvSpPr>
+          <p:cNvPr id="16" name="Text 13"/>
+          <p:cNvSpPr txBox="1"/>
+          <p:nvPr/>
+        </p:nvSpPr>
+        <p:spPr>
+          <a:xfrm>
+            <a:off x="6995160" y="3840480"/>
+            <a:ext cx="4297680" cy="2743200"/>
+          </a:xfrm>
+          <a:prstGeom prst="rect">
+            <a:avLst/>
+          </a:prstGeom>
+          <a:noFill/>
+          <a:ln/>
+        </p:spPr>
+        <p:txBody>
+          <a:bodyPr wrap="square" lIns="0" tIns="0" rIns="0" bIns="0" rtlCol="0" anchor="t"/>
+          <a:lstStyle/>
+          <a:p>
+            <a:pPr indent="0" marL="0">
+              <a:lnSpc>
+                <a:spcPct val="125000"/>
+              </a:lnSpc>
+              <a:buNone/>
+            </a:pPr>
+            <a:r>
+              <a:rPr lang="en-US" sz="2300" dirty="0">
+                <a:solidFill>
+                  <a:srgbClr val="5A6571"/>
+                </a:solidFill>
+                <a:latin typeface="Futura" pitchFamily="34" charset="0"/>
+                <a:ea typeface="Futura" pitchFamily="34" charset="-122"/>
+                <a:cs typeface="Futura" pitchFamily="34" charset="-120"/>
+              </a:rPr>
+              <a:t>It learned from writing that reflects society's inequities, so answers can repeat stereotypes. Our work affects real communities.</a:t>
+            </a:r>
+            <a:endParaRPr lang="en-US" sz="2300" dirty="0"/>
+          </a:p>
+        </p:txBody>
+      </p:sp>
+      <p:sp>
+        <p:nvSpPr>
+          <p:cNvPr id="17" name="Shape 14"/>
+          <p:cNvSpPr/>
+          <p:nvPr/>
+        </p:nvSpPr>
+        <p:spPr>
+          <a:xfrm>
+            <a:off x="12230100" y="2697480"/>
+            <a:ext cx="5029200" cy="4206240"/>
+          </a:xfrm>
+          <a:prstGeom prst="rect">
+            <a:avLst/>
+          </a:prstGeom>
+          <a:solidFill>
+            <a:srgbClr val="FFFFFF"/>
+          </a:solidFill>
+          <a:ln w="9525">
+            <a:solidFill>
+              <a:srgbClr val="D0D3D4"/>
+            </a:solidFill>
+            <a:prstDash val="solid"/>
+          </a:ln>
+        </p:spPr>
+      </p:sp>
+      <p:sp>
+        <p:nvSpPr>
+          <p:cNvPr id="18" name="Shape 15"/>
+          <p:cNvSpPr/>
+          <p:nvPr/>
+        </p:nvSpPr>
+        <p:spPr>
+          <a:xfrm>
+            <a:off x="12230100" y="2697480"/>
+            <a:ext cx="5029200" cy="91440"/>
+          </a:xfrm>
+          <a:prstGeom prst="rect">
+            <a:avLst/>
+          </a:prstGeom>
+          <a:solidFill>
+            <a:srgbClr val="FFC600"/>
+          </a:solidFill>
+          <a:ln/>
+        </p:spPr>
+      </p:sp>
+      <p:sp>
+        <p:nvSpPr>
+          <p:cNvPr id="19" name="Text 16"/>
+          <p:cNvSpPr txBox="1"/>
+          <p:nvPr/>
+        </p:nvSpPr>
+        <p:spPr>
+          <a:xfrm>
+            <a:off x="12595860" y="3108960"/>
+            <a:ext cx="4297680" cy="548640"/>
+          </a:xfrm>
+          <a:prstGeom prst="rect">
+            <a:avLst/>
+          </a:prstGeom>
+          <a:noFill/>
+          <a:ln/>
+        </p:spPr>
+        <p:txBody>
+          <a:bodyPr wrap="square" lIns="0" tIns="0" rIns="0" bIns="0" rtlCol="0" anchor="t"/>
+          <a:lstStyle/>
+          <a:p>
+            <a:pPr indent="0" marL="0">
+              <a:buNone/>
+            </a:pPr>
+            <a:r>
+              <a:rPr lang="en-US" sz="3100" b="1" dirty="0">
+                <a:solidFill>
+                  <a:srgbClr val="07294D"/>
+                </a:solidFill>
+                <a:latin typeface="Georgia" pitchFamily="34" charset="0"/>
+                <a:ea typeface="Georgia" pitchFamily="34" charset="-122"/>
+                <a:cs typeface="Georgia" pitchFamily="34" charset="-120"/>
+              </a:rPr>
+              <a:t>You Are Responsible</a:t>
+            </a:r>
+            <a:endParaRPr lang="en-US" sz="3100" dirty="0"/>
+          </a:p>
+        </p:txBody>
+      </p:sp>
+      <p:sp>
+        <p:nvSpPr>
+          <p:cNvPr id="20" name="Text 17"/>
+          <p:cNvSpPr txBox="1"/>
+          <p:nvPr/>
+        </p:nvSpPr>
+        <p:spPr>
+          <a:xfrm>
+            <a:off x="12595860" y="3840480"/>
+            <a:ext cx="4297680" cy="2743200"/>
+          </a:xfrm>
+          <a:prstGeom prst="rect">
+            <a:avLst/>
+          </a:prstGeom>
+          <a:noFill/>
+          <a:ln/>
+        </p:spPr>
+        <p:txBody>
+          <a:bodyPr wrap="square" lIns="0" tIns="0" rIns="0" bIns="0" rtlCol="0" anchor="t"/>
+          <a:lstStyle/>
+          <a:p>
+            <a:pPr indent="0" marL="0">
+              <a:lnSpc>
+                <a:spcPct val="125000"/>
+              </a:lnSpc>
+              <a:buNone/>
+            </a:pPr>
+            <a:r>
+              <a:rPr lang="en-US" sz="2300" dirty="0">
+                <a:solidFill>
+                  <a:srgbClr val="5A6571"/>
+                </a:solidFill>
+                <a:latin typeface="Futura" pitchFamily="34" charset="0"/>
+                <a:ea typeface="Futura" pitchFamily="34" charset="-122"/>
+                <a:cs typeface="Futura" pitchFamily="34" charset="-120"/>
+              </a:rPr>
+              <a:t>If your name is on it, you own it: accuracy, fairness, and tone. “The AI wrote it” is never the answer.</a:t>
+            </a:r>
+            <a:endParaRPr lang="en-US" sz="2300" dirty="0"/>
+          </a:p>
+        </p:txBody>
+      </p:sp>
+    </p:spTree>
+  </p:cSld>
+  <p:clrMapOvr>
+    <a:masterClrMapping/>
+  </p:clrMapOvr>
+</p:sld>
+</file>
+
+<file path=ppt/slides/slide15.xml><?xml version="1.0" encoding="utf-8"?>
+<p:sld xmlns:a="http://schemas.openxmlformats.org/drawingml/2006/main" xmlns:r="http://schemas.openxmlformats.org/officeDocument/2006/relationships" xmlns:p="http://schemas.openxmlformats.org/presentationml/2006/main">
+  <p:cSld name="Slide 9">
+    <p:bg>
+      <p:bgPr>
+        <a:solidFill>
+          <a:srgbClr val="07294D"/>
+        </a:solidFill>
+      </p:bgPr>
+    </p:bg>
+    <p:spTree>
+      <p:nvGrpSpPr>
+        <p:cNvPr id="1" name=""/>
+        <p:cNvGrpSpPr/>
+        <p:nvPr/>
+      </p:nvGrpSpPr>
+      <p:grpSpPr>
+        <a:xfrm>
+          <a:off x="0" y="0"/>
+          <a:ext cx="0" cy="0"/>
+          <a:chOff x="0" y="0"/>
+          <a:chExt cx="0" cy="0"/>
+        </a:xfrm>
+      </p:grpSpPr>
+      <p:sp>
+        <p:nvSpPr>
+          <p:cNvPr id="2" name="Text 0"/>
+          <p:cNvSpPr txBox="1"/>
+          <p:nvPr/>
+        </p:nvSpPr>
+        <p:spPr>
+          <a:xfrm>
+            <a:off x="1028700" y="3383280"/>
+            <a:ext cx="16230600" cy="274320"/>
+          </a:xfrm>
+          <a:prstGeom prst="rect">
+            <a:avLst/>
+          </a:prstGeom>
+          <a:noFill/>
+          <a:ln/>
+        </p:spPr>
+        <p:txBody>
+          <a:bodyPr wrap="square" lIns="0" tIns="0" rIns="0" bIns="0" rtlCol="0" anchor="t"/>
+          <a:lstStyle/>
+          <a:p>
+            <a:pPr indent="0" marL="0">
+              <a:buNone/>
+            </a:pPr>
+            <a:r>
+              <a:rPr lang="en-US" sz="1800" b="1" spc="300" kern="0" dirty="0">
+                <a:solidFill>
+                  <a:srgbClr val="FFC600"/>
+                </a:solidFill>
+                <a:latin typeface="Futura" pitchFamily="34" charset="0"/>
+                <a:ea typeface="Futura" pitchFamily="34" charset="-122"/>
+                <a:cs typeface="Futura" pitchFamily="34" charset="-120"/>
+              </a:rPr>
+              <a:t>SECTION 04</a:t>
+            </a:r>
+            <a:endParaRPr lang="en-US" sz="1800" dirty="0"/>
+          </a:p>
+        </p:txBody>
+      </p:sp>
+      <p:sp>
+        <p:nvSpPr>
+          <p:cNvPr id="3" name="Text 1"/>
+          <p:cNvSpPr txBox="1"/>
+          <p:nvPr/>
+        </p:nvSpPr>
+        <p:spPr>
+          <a:xfrm>
+            <a:off x="1028700" y="3749040"/>
+            <a:ext cx="16230600" cy="1097280"/>
+          </a:xfrm>
+          <a:prstGeom prst="rect">
+            <a:avLst/>
+          </a:prstGeom>
+          <a:noFill/>
+          <a:ln/>
+        </p:spPr>
+        <p:txBody>
+          <a:bodyPr wrap="square" lIns="0" tIns="0" rIns="0" bIns="0" rtlCol="0" anchor="ctr"/>
+          <a:lstStyle/>
+          <a:p>
+            <a:pPr indent="0" marL="0">
+              <a:buNone/>
+            </a:pPr>
+            <a:r>
+              <a:rPr lang="en-US" sz="7400" b="1" dirty="0">
+                <a:solidFill>
+                  <a:srgbClr val="FFFFFF"/>
+                </a:solidFill>
+                <a:latin typeface="Georgia" pitchFamily="34" charset="0"/>
+                <a:ea typeface="Georgia" pitchFamily="34" charset="-122"/>
+                <a:cs typeface="Georgia" pitchFamily="34" charset="-120"/>
+              </a:rPr>
+              <a:t>Hands-On</a:t>
+            </a:r>
+            <a:endParaRPr lang="en-US" sz="7400" dirty="0"/>
+          </a:p>
+        </p:txBody>
+      </p:sp>
+      <p:sp>
+        <p:nvSpPr>
+          <p:cNvPr id="4" name="Shape 2"/>
+          <p:cNvSpPr/>
+          <p:nvPr/>
+        </p:nvSpPr>
+        <p:spPr>
+          <a:xfrm>
+            <a:off x="1028700" y="5074920"/>
+            <a:ext cx="777240" cy="73152"/>
+          </a:xfrm>
+          <a:prstGeom prst="rect">
+            <a:avLst/>
+          </a:prstGeom>
+          <a:solidFill>
+            <a:srgbClr val="FFC600"/>
+          </a:solidFill>
+          <a:ln/>
+        </p:spPr>
+        <p:txBody>
+          <a:bodyPr/>
+          <a:p/>
+        </p:txBody>
+      </p:sp>
+      <p:sp>
+        <p:nvSpPr>
+          <p:cNvPr id="5" name="Text 3"/>
+          <p:cNvSpPr txBox="1"/>
+          <p:nvPr/>
+        </p:nvSpPr>
+        <p:spPr>
+          <a:xfrm>
+            <a:off x="1028700" y="5486400"/>
+            <a:ext cx="13258800" cy="914400"/>
+          </a:xfrm>
+          <a:prstGeom prst="rect">
+            <a:avLst/>
+          </a:prstGeom>
+          <a:noFill/>
+          <a:ln/>
+        </p:spPr>
+        <p:txBody>
+          <a:bodyPr wrap="square" lIns="0" tIns="0" rIns="0" bIns="0" rtlCol="0" anchor="t"/>
+          <a:lstStyle/>
+          <a:p>
+            <a:pPr indent="0" marL="0">
+              <a:buNone/>
+            </a:pPr>
+            <a:r>
+              <a:rPr lang="en-US" sz="2800" dirty="0">
+                <a:solidFill>
+                  <a:srgbClr val="C7D2DF"/>
+                </a:solidFill>
+                <a:latin typeface="Futura" pitchFamily="34" charset="0"/>
+                <a:ea typeface="Futura" pitchFamily="34" charset="-122"/>
+                <a:cs typeface="Futura" pitchFamily="34" charset="-120"/>
+              </a:rPr>
+              <a:t>A guided tour, three first requests, and a simple recipe for better answers.</a:t>
+            </a:r>
+            <a:endParaRPr lang="en-US" sz="2800" dirty="0"/>
+          </a:p>
+        </p:txBody>
+      </p:sp>
+    </p:spTree>
+  </p:cSld>
+  <p:clrMapOvr>
+    <a:masterClrMapping/>
+  </p:clrMapOvr>
+</p:sld>
+</file>
+
+<file path=ppt/slides/slide16.xml><?xml version="1.0" encoding="utf-8"?>
 <p:sld xmlns:a="http://schemas.openxmlformats.org/drawingml/2006/main" xmlns:r="http://schemas.openxmlformats.org/officeDocument/2006/relationships" xmlns:p="http://schemas.openxmlformats.org/presentationml/2006/main">
   <p:cSld name="Slide 10">
     <p:bg>
@@ -3793,7 +4945,7 @@
 </p:sld>
 </file>
 
-<file path=ppt/slides/slide11.xml><?xml version="1.0" encoding="utf-8"?>
+<file path=ppt/slides/slide17.xml><?xml version="1.0" encoding="utf-8"?>
 <p:sld xmlns:a="http://schemas.openxmlformats.org/drawingml/2006/main" xmlns:r="http://schemas.openxmlformats.org/officeDocument/2006/relationships" xmlns:p="http://schemas.openxmlformats.org/presentationml/2006/main">
   <p:cSld name="Slide 11">
     <p:bg>
@@ -4260,7 +5412,7 @@
 </p:sld>
 </file>
 
-<file path=ppt/slides/slide12.xml><?xml version="1.0" encoding="utf-8"?>
+<file path=ppt/slides/slide18.xml><?xml version="1.0" encoding="utf-8"?>
 <p:sld xmlns:a="http://schemas.openxmlformats.org/drawingml/2006/main" xmlns:r="http://schemas.openxmlformats.org/officeDocument/2006/relationships" xmlns:p="http://schemas.openxmlformats.org/presentationml/2006/main">
   <p:cSld name="Slide 12">
     <p:bg>
@@ -4973,7 +6125,7 @@
 </p:sld>
 </file>
 
-<file path=ppt/slides/slide13.xml><?xml version="1.0" encoding="utf-8"?>
+<file path=ppt/slides/slide19.xml><?xml version="1.0" encoding="utf-8"?>
 <p:sld xmlns:a="http://schemas.openxmlformats.org/drawingml/2006/main" xmlns:r="http://schemas.openxmlformats.org/officeDocument/2006/relationships" xmlns:p="http://schemas.openxmlformats.org/presentationml/2006/main">
   <p:cSld name="Slide 13">
     <p:bg>
@@ -5329,726 +6481,6 @@
           </a:p>
         </p:txBody>
       </p:sp>
-    </p:spTree>
-  </p:cSld>
-  <p:clrMapOvr>
-    <a:masterClrMapping/>
-  </p:clrMapOvr>
-</p:sld>
-</file>
-
-<file path=ppt/slides/slide14.xml><?xml version="1.0" encoding="utf-8"?>
-<p:sld xmlns:a="http://schemas.openxmlformats.org/drawingml/2006/main" xmlns:r="http://schemas.openxmlformats.org/officeDocument/2006/relationships" xmlns:p="http://schemas.openxmlformats.org/presentationml/2006/main">
-  <p:cSld name="Slide 14">
-    <p:bg>
-      <p:bgPr>
-        <a:solidFill>
-          <a:srgbClr val="07294D"/>
-        </a:solidFill>
-      </p:bgPr>
-    </p:bg>
-    <p:spTree>
-      <p:nvGrpSpPr>
-        <p:cNvPr id="1" name=""/>
-        <p:cNvGrpSpPr/>
-        <p:nvPr/>
-      </p:nvGrpSpPr>
-      <p:grpSpPr>
-        <a:xfrm>
-          <a:off x="0" y="0"/>
-          <a:ext cx="0" cy="0"/>
-          <a:chOff x="0" y="0"/>
-          <a:chExt cx="0" cy="0"/>
-        </a:xfrm>
-      </p:grpSpPr>
-      <p:sp>
-        <p:nvSpPr>
-          <p:cNvPr id="2" name="Shape 0"/>
-          <p:cNvSpPr/>
-          <p:nvPr/>
-        </p:nvSpPr>
-        <p:spPr>
-          <a:xfrm>
-            <a:off x="1028700" y="859536"/>
-            <a:ext cx="4480560" cy="1005840"/>
-          </a:xfrm>
-          <a:prstGeom prst="roundRect">
-            <a:avLst>
-              <a:gd name="adj" fmla="val 10909"/>
-            </a:avLst>
-          </a:prstGeom>
-          <a:solidFill>
-            <a:srgbClr val="FFFFFF"/>
-          </a:solidFill>
-          <a:ln/>
-        </p:spPr>
-      </p:sp>
-      <p:sp>
-        <p:nvSpPr>
-          <p:cNvPr id="3" name="Text 1"/>
-          <p:cNvSpPr txBox="1"/>
-          <p:nvPr/>
-        </p:nvSpPr>
-        <p:spPr>
-          <a:xfrm>
-            <a:off x="1339596" y="987552"/>
-            <a:ext cx="4023360" cy="384048"/>
-          </a:xfrm>
-          <a:prstGeom prst="rect">
-            <a:avLst/>
-          </a:prstGeom>
-          <a:noFill/>
-          <a:ln/>
-        </p:spPr>
-        <p:txBody>
-          <a:bodyPr wrap="square" lIns="0" tIns="0" rIns="0" bIns="0" rtlCol="0" anchor="t"/>
-          <a:lstStyle/>
-          <a:p>
-            <a:pPr indent="0" marL="0">
-              <a:buNone/>
-            </a:pPr>
-            <a:r>
-              <a:rPr lang="en-US" sz="2400" b="1" dirty="0">
-                <a:solidFill>
-                  <a:srgbClr val="07294D"/>
-                </a:solidFill>
-                <a:latin typeface="Georgia" pitchFamily="34" charset="0"/>
-                <a:ea typeface="Georgia" pitchFamily="34" charset="-122"/>
-                <a:cs typeface="Georgia" pitchFamily="34" charset="-120"/>
-              </a:rPr>
-              <a:t>Drexel University</a:t>
-            </a:r>
-            <a:endParaRPr lang="en-US" sz="2400" dirty="0"/>
-          </a:p>
-        </p:txBody>
-      </p:sp>
-      <p:sp>
-        <p:nvSpPr>
-          <p:cNvPr id="4" name="Text 2"/>
-          <p:cNvSpPr txBox="1"/>
-          <p:nvPr/>
-        </p:nvSpPr>
-        <p:spPr>
-          <a:xfrm>
-            <a:off x="1339596" y="1417320"/>
-            <a:ext cx="4023360" cy="310896"/>
-          </a:xfrm>
-          <a:prstGeom prst="rect">
-            <a:avLst/>
-          </a:prstGeom>
-          <a:noFill/>
-          <a:ln/>
-        </p:spPr>
-        <p:txBody>
-          <a:bodyPr wrap="square" lIns="0" tIns="0" rIns="0" bIns="0" rtlCol="0" anchor="t"/>
-          <a:lstStyle/>
-          <a:p>
-            <a:pPr indent="0" marL="0">
-              <a:buNone/>
-            </a:pPr>
-            <a:r>
-              <a:rPr lang="en-US" sz="1600" b="1" dirty="0">
-                <a:solidFill>
-                  <a:srgbClr val="006699"/>
-                </a:solidFill>
-                <a:latin typeface="Futura" pitchFamily="34" charset="0"/>
-                <a:ea typeface="Futura" pitchFamily="34" charset="-122"/>
-                <a:cs typeface="Futura" pitchFamily="34" charset="-120"/>
-              </a:rPr>
-              <a:t>Dornsife School of Public Health</a:t>
-            </a:r>
-            <a:endParaRPr lang="en-US" sz="1600" dirty="0"/>
-          </a:p>
-        </p:txBody>
-      </p:sp>
-      <p:sp>
-        <p:nvSpPr>
-          <p:cNvPr id="5" name="Text 3"/>
-          <p:cNvSpPr txBox="1"/>
-          <p:nvPr/>
-        </p:nvSpPr>
-        <p:spPr>
-          <a:xfrm>
-            <a:off x="1028700" y="4069080"/>
-            <a:ext cx="16230600" cy="274320"/>
-          </a:xfrm>
-          <a:prstGeom prst="rect">
-            <a:avLst/>
-          </a:prstGeom>
-          <a:noFill/>
-          <a:ln/>
-        </p:spPr>
-        <p:txBody>
-          <a:bodyPr wrap="square" lIns="0" tIns="0" rIns="0" bIns="0" rtlCol="0" anchor="t"/>
-          <a:lstStyle/>
-          <a:p>
-            <a:pPr indent="0" marL="0">
-              <a:buNone/>
-            </a:pPr>
-            <a:r>
-              <a:rPr lang="en-US" sz="1800" b="1" spc="300" kern="0" dirty="0">
-                <a:solidFill>
-                  <a:srgbClr val="FFC600"/>
-                </a:solidFill>
-                <a:latin typeface="Futura" pitchFamily="34" charset="0"/>
-                <a:ea typeface="Futura" pitchFamily="34" charset="-122"/>
-                <a:cs typeface="Futura" pitchFamily="34" charset="-120"/>
-              </a:rPr>
-              <a:t>THANK YOU</a:t>
-            </a:r>
-            <a:endParaRPr lang="en-US" sz="1800" dirty="0"/>
-          </a:p>
-        </p:txBody>
-      </p:sp>
-      <p:sp>
-        <p:nvSpPr>
-          <p:cNvPr id="6" name="Text 4"/>
-          <p:cNvSpPr txBox="1"/>
-          <p:nvPr/>
-        </p:nvSpPr>
-        <p:spPr>
-          <a:xfrm>
-            <a:off x="1028700" y="4434840"/>
-            <a:ext cx="16230600" cy="1371600"/>
-          </a:xfrm>
-          <a:prstGeom prst="rect">
-            <a:avLst/>
-          </a:prstGeom>
-          <a:noFill/>
-          <a:ln/>
-        </p:spPr>
-        <p:txBody>
-          <a:bodyPr wrap="square" lIns="0" tIns="0" rIns="0" bIns="0" rtlCol="0" anchor="ctr"/>
-          <a:lstStyle/>
-          <a:p>
-            <a:pPr indent="0" marL="0">
-              <a:buNone/>
-            </a:pPr>
-            <a:r>
-              <a:rPr lang="en-US" sz="8900" b="1" dirty="0">
-                <a:solidFill>
-                  <a:srgbClr val="FFFFFF"/>
-                </a:solidFill>
-                <a:latin typeface="Georgia" pitchFamily="34" charset="0"/>
-                <a:ea typeface="Georgia" pitchFamily="34" charset="-122"/>
-                <a:cs typeface="Georgia" pitchFamily="34" charset="-120"/>
-              </a:rPr>
-              <a:t>Questions &amp; Discussion</a:t>
-            </a:r>
-            <a:endParaRPr lang="en-US" sz="8900" dirty="0"/>
-          </a:p>
-        </p:txBody>
-      </p:sp>
-      <p:sp>
-        <p:nvSpPr>
-          <p:cNvPr id="7" name="Shape 5"/>
-          <p:cNvSpPr/>
-          <p:nvPr/>
-        </p:nvSpPr>
-        <p:spPr>
-          <a:xfrm>
-            <a:off x="1028700" y="6035040"/>
-            <a:ext cx="777240" cy="73152"/>
-          </a:xfrm>
-          <a:prstGeom prst="rect">
-            <a:avLst/>
-          </a:prstGeom>
-          <a:solidFill>
-            <a:srgbClr val="FFC600"/>
-          </a:solidFill>
-          <a:ln/>
-        </p:spPr>
-      </p:sp>
-      <p:sp>
-        <p:nvSpPr>
-          <p:cNvPr id="8" name="Text 6"/>
-          <p:cNvSpPr txBox="1"/>
-          <p:nvPr/>
-        </p:nvSpPr>
-        <p:spPr>
-          <a:xfrm>
-            <a:off x="1028700" y="6400800"/>
-            <a:ext cx="14173200" cy="914400"/>
-          </a:xfrm>
-          <a:prstGeom prst="rect">
-            <a:avLst/>
-          </a:prstGeom>
-          <a:noFill/>
-          <a:ln/>
-        </p:spPr>
-        <p:txBody>
-          <a:bodyPr wrap="square" lIns="0" tIns="0" rIns="0" bIns="0" rtlCol="0" anchor="t"/>
-          <a:lstStyle/>
-          <a:p>
-            <a:pPr indent="0" marL="0">
-              <a:buNone/>
-            </a:pPr>
-            <a:r>
-              <a:rPr lang="en-US" sz="2600" dirty="0">
-                <a:solidFill>
-                  <a:srgbClr val="C7D2DF"/>
-                </a:solidFill>
-                <a:latin typeface="Futura" pitchFamily="34" charset="0"/>
-                <a:ea typeface="Futura" pitchFamily="34" charset="-122"/>
-                <a:cs typeface="Futura" pitchFamily="34" charset="-120"/>
-              </a:rPr>
-              <a:t>Next: Core 2 — Workflow Enhancement. Use Copilot and ChatGPT Edu to speed up the work you already do.</a:t>
-            </a:r>
-            <a:endParaRPr lang="en-US" sz="2600" dirty="0"/>
-          </a:p>
-        </p:txBody>
-      </p:sp>
-      <p:sp>
-        <p:nvSpPr>
-          <p:cNvPr id="9" name="Text 7"/>
-          <p:cNvSpPr txBox="1"/>
-          <p:nvPr/>
-        </p:nvSpPr>
-        <p:spPr>
-          <a:xfrm>
-            <a:off x="1028700" y="8686800"/>
-            <a:ext cx="9144000" cy="365760"/>
-          </a:xfrm>
-          <a:prstGeom prst="rect">
-            <a:avLst/>
-          </a:prstGeom>
-          <a:noFill/>
-          <a:ln/>
-        </p:spPr>
-        <p:txBody>
-          <a:bodyPr wrap="square" lIns="0" tIns="0" rIns="0" bIns="0" rtlCol="0" anchor="t"/>
-          <a:lstStyle/>
-          <a:p>
-            <a:pPr indent="0" marL="0">
-              <a:buNone/>
-            </a:pPr>
-            <a:r>
-              <a:rPr lang="en-US" sz="2300" b="1" dirty="0">
-                <a:solidFill>
-                  <a:srgbClr val="FFFFFF"/>
-                </a:solidFill>
-                <a:latin typeface="Futura" pitchFamily="34" charset="0"/>
-                <a:ea typeface="Futura" pitchFamily="34" charset="-122"/>
-                <a:cs typeface="Futura" pitchFamily="34" charset="-120"/>
-              </a:rPr>
-              <a:t>Alex Quistberg, PhD, MPH</a:t>
-            </a:r>
-            <a:endParaRPr lang="en-US" sz="2300" dirty="0"/>
-          </a:p>
-        </p:txBody>
-      </p:sp>
-      <p:sp>
-        <p:nvSpPr>
-          <p:cNvPr id="10" name="Text 8"/>
-          <p:cNvSpPr txBox="1"/>
-          <p:nvPr/>
-        </p:nvSpPr>
-        <p:spPr>
-          <a:xfrm>
-            <a:off x="1028700" y="9070848"/>
-            <a:ext cx="10058400" cy="320040"/>
-          </a:xfrm>
-          <a:prstGeom prst="rect">
-            <a:avLst/>
-          </a:prstGeom>
-          <a:noFill/>
-          <a:ln/>
-        </p:spPr>
-        <p:txBody>
-          <a:bodyPr wrap="square" lIns="0" tIns="0" rIns="0" bIns="0" rtlCol="0" anchor="t"/>
-          <a:lstStyle/>
-          <a:p>
-            <a:pPr indent="0" marL="0">
-              <a:buNone/>
-            </a:pPr>
-            <a:r>
-              <a:rPr lang="en-US" sz="1900" dirty="0">
-                <a:solidFill>
-                  <a:srgbClr val="9FB3CC"/>
-                </a:solidFill>
-                <a:latin typeface="Futura" pitchFamily="34" charset="0"/>
-                <a:ea typeface="Futura" pitchFamily="34" charset="-122"/>
-                <a:cs typeface="Futura" pitchFamily="34" charset="-120"/>
-              </a:rPr>
-              <a:t>daq26@drexel.edu</a:t>
-            </a:r>
-            <a:endParaRPr lang="en-US" sz="1900" dirty="0"/>
-          </a:p>
-        </p:txBody>
-      </p:sp>
-      <p:sp>
-        <p:nvSpPr>
-          <p:cNvPr id="11" name="Text 9"/>
-          <p:cNvSpPr txBox="1"/>
-          <p:nvPr/>
-        </p:nvSpPr>
-        <p:spPr>
-          <a:xfrm>
-            <a:off x="9509760" y="9070848"/>
-            <a:ext cx="7772400" cy="320040"/>
-          </a:xfrm>
-          <a:prstGeom prst="rect">
-            <a:avLst/>
-          </a:prstGeom>
-          <a:noFill/>
-          <a:ln/>
-        </p:spPr>
-        <p:txBody>
-          <a:bodyPr wrap="square" lIns="0" tIns="0" rIns="0" bIns="0" rtlCol="0" anchor="t"/>
-          <a:lstStyle/>
-          <a:p>
-            <a:pPr algn="r" indent="0" marL="0">
-              <a:buNone/>
-            </a:pPr>
-            <a:r>
-              <a:rPr lang="en-US" sz="1900" dirty="0">
-                <a:solidFill>
-                  <a:srgbClr val="9FB3CC"/>
-                </a:solidFill>
-                <a:latin typeface="Futura" pitchFamily="34" charset="0"/>
-                <a:ea typeface="Futura" pitchFamily="34" charset="-122"/>
-                <a:cs typeface="Futura" pitchFamily="34" charset="-120"/>
-              </a:rPr>
-              <a:t>Department of Environmental &amp; Occupational Health</a:t>
-            </a:r>
-            <a:endParaRPr lang="en-US" sz="1900" dirty="0"/>
-          </a:p>
-        </p:txBody>
-      </p:sp>
-    </p:spTree>
-  </p:cSld>
-  <p:clrMapOvr>
-    <a:masterClrMapping/>
-  </p:clrMapOvr>
-</p:sld>
-</file>
-
-<file path=ppt/slides/slide15.xml><?xml version="1.0" encoding="utf-8"?>
-<p:sld xmlns:a="http://schemas.openxmlformats.org/drawingml/2006/main" xmlns:p="http://schemas.openxmlformats.org/presentationml/2006/main" xmlns:r="http://schemas.openxmlformats.org/officeDocument/2006/relationships">
-  <p:cSld>
-    <p:bg>
-      <p:bgPr>
-        <a:solidFill>
-          <a:srgbClr val="07294D"/>
-        </a:solidFill>
-      </p:bgPr>
-    </p:bg>
-    <p:spTree>
-      <p:nvGrpSpPr>
-        <p:cNvPr id="1" name=""/>
-        <p:cNvGrpSpPr/>
-        <p:nvPr/>
-      </p:nvGrpSpPr>
-      <p:grpSpPr/>
-      <p:sp>
-        <p:nvSpPr>
-          <p:cNvPr id="2" name="Text 0"/>
-          <p:cNvSpPr txBox="1"/>
-          <p:nvPr/>
-        </p:nvSpPr>
-        <p:spPr>
-          <a:xfrm>
-            <a:off x="1028700" y="3383280"/>
-            <a:ext cx="16230600" cy="274320"/>
-          </a:xfrm>
-          <a:prstGeom prst="rect">
-            <a:avLst/>
-          </a:prstGeom>
-          <a:noFill/>
-          <a:ln/>
-        </p:spPr>
-        <p:txBody>
-          <a:bodyPr wrap="square" lIns="0" tIns="0" rIns="0" bIns="0" rtlCol="0" anchor="t"/>
-          <a:lstStyle/>
-          <a:p>
-            <a:pPr indent="0" marL="0">
-              <a:buNone/>
-            </a:pPr>
-            <a:r>
-              <a:rPr lang="en-US" sz="1800" b="1" spc="300" kern="0" dirty="0">
-                <a:solidFill>
-                  <a:srgbClr val="FFC600"/>
-                </a:solidFill>
-                <a:latin typeface="Futura" pitchFamily="34" charset="0"/>
-                <a:ea typeface="Futura" pitchFamily="34" charset="-122"/>
-                <a:cs typeface="Futura" pitchFamily="34" charset="-120"/>
-              </a:rPr>
-              <a:t>SECTION 02</a:t>
-            </a:r>
-            <a:endParaRPr lang="en-US" sz="1800" dirty="0"/>
-          </a:p>
-        </p:txBody>
-      </p:sp>
-      <p:sp>
-        <p:nvSpPr>
-          <p:cNvPr id="3" name="Text 1"/>
-          <p:cNvSpPr txBox="1"/>
-          <p:nvPr/>
-        </p:nvSpPr>
-        <p:spPr>
-          <a:xfrm>
-            <a:off x="1028700" y="3749040"/>
-            <a:ext cx="16230600" cy="1097280"/>
-          </a:xfrm>
-          <a:prstGeom prst="rect">
-            <a:avLst/>
-          </a:prstGeom>
-          <a:noFill/>
-          <a:ln/>
-        </p:spPr>
-        <p:txBody>
-          <a:bodyPr wrap="square" lIns="0" tIns="0" rIns="0" bIns="0" rtlCol="0" anchor="ctr"/>
-          <a:lstStyle/>
-          <a:p>
-            <a:pPr indent="0" marL="0">
-              <a:buNone/>
-            </a:pPr>
-            <a:r>
-              <a:rPr lang="en-US" sz="7400" b="1" dirty="0">
-                <a:solidFill>
-                  <a:srgbClr val="FFFFFF"/>
-                </a:solidFill>
-                <a:latin typeface="Georgia" pitchFamily="34" charset="0"/>
-                <a:ea typeface="Georgia" pitchFamily="34" charset="-122"/>
-                <a:cs typeface="Georgia" pitchFamily="34" charset="-120"/>
-              </a:rPr>
-              <a:t>What It Can Do</a:t>
-            </a:r>
-            <a:endParaRPr lang="en-US" sz="7400" dirty="0"/>
-          </a:p>
-        </p:txBody>
-      </p:sp>
-      <p:sp>
-        <p:nvSpPr>
-          <p:cNvPr id="4" name="Shape 2"/>
-          <p:cNvSpPr/>
-          <p:nvPr/>
-        </p:nvSpPr>
-        <p:spPr>
-          <a:xfrm>
-            <a:off x="1028700" y="5074920"/>
-            <a:ext cx="777240" cy="73152"/>
-          </a:xfrm>
-          <a:prstGeom prst="rect">
-            <a:avLst/>
-          </a:prstGeom>
-          <a:solidFill>
-            <a:srgbClr val="FFC600"/>
-          </a:solidFill>
-          <a:ln/>
-        </p:spPr>
-        <p:txBody>
-          <a:bodyPr/>
-          <a:p/>
-        </p:txBody>
-      </p:sp>
-      <p:sp>
-        <p:nvSpPr>
-          <p:cNvPr id="5" name="Text 3"/>
-          <p:cNvSpPr txBox="1"/>
-          <p:nvPr/>
-        </p:nvSpPr>
-        <p:spPr>
-          <a:xfrm>
-            <a:off x="1028700" y="5486400"/>
-            <a:ext cx="13258800" cy="914400"/>
-          </a:xfrm>
-          <a:prstGeom prst="rect">
-            <a:avLst/>
-          </a:prstGeom>
-          <a:noFill/>
-          <a:ln/>
-        </p:spPr>
-        <p:txBody>
-          <a:bodyPr wrap="square" lIns="0" tIns="0" rIns="0" bIns="0" rtlCol="0" anchor="t"/>
-          <a:lstStyle/>
-          <a:p>
-            <a:pPr indent="0" marL="0">
-              <a:buNone/>
-            </a:pPr>
-            <a:r>
-              <a:rPr lang="en-US" sz="2800" dirty="0">
-                <a:solidFill>
-                  <a:srgbClr val="C7D2DF"/>
-                </a:solidFill>
-                <a:latin typeface="Futura" pitchFamily="34" charset="0"/>
-                <a:ea typeface="Futura" pitchFamily="34" charset="-122"/>
-                <a:cs typeface="Futura" pitchFamily="34" charset="-120"/>
-              </a:rPr>
-              <a:t>Five real tasks from public health work: analyze data, review a draft, build slides, sort an inbox, find sources, and one look past the chat box.</a:t>
-            </a:r>
-            <a:endParaRPr lang="en-US" sz="2800" dirty="0"/>
-          </a:p>
-        </p:txBody>
-      </p:sp>
-    </p:spTree>
-  </p:cSld>
-  <p:clrMapOvr>
-    <a:masterClrMapping/>
-  </p:clrMapOvr>
-</p:sld>
-</file>
-
-<file path=ppt/slides/slide16.xml><?xml version="1.0" encoding="utf-8"?>
-<p:sld xmlns:a="http://schemas.openxmlformats.org/drawingml/2006/main" xmlns:p="http://schemas.openxmlformats.org/presentationml/2006/main" xmlns:r="http://schemas.openxmlformats.org/officeDocument/2006/relationships">
-  <p:cSld>
-    <p:spTree>
-      <p:nvGrpSpPr>
-        <p:cNvPr id="1" name=""/>
-        <p:cNvGrpSpPr/>
-        <p:nvPr/>
-      </p:nvGrpSpPr>
-      <p:grpSpPr/>
-      <p:pic>
-        <p:nvPicPr>
-          <p:cNvPr id="2" name="Picture 1" descr="hi8.png"/>
-          <p:cNvPicPr>
-            <a:picLocks noChangeAspect="1"/>
-          </p:cNvPicPr>
-          <p:nvPr/>
-        </p:nvPicPr>
-        <p:blipFill>
-          <a:blip r:embed="rId2"/>
-          <a:stretch>
-            <a:fillRect/>
-          </a:stretch>
-        </p:blipFill>
-        <p:spPr>
-          <a:xfrm>
-            <a:off x="0" y="0"/>
-            <a:ext cx="18288000" cy="10287000"/>
-          </a:xfrm>
-          <a:prstGeom prst="rect">
-            <a:avLst/>
-          </a:prstGeom>
-        </p:spPr>
-      </p:pic>
-    </p:spTree>
-  </p:cSld>
-  <p:clrMapOvr>
-    <a:masterClrMapping/>
-  </p:clrMapOvr>
-</p:sld>
-</file>
-
-<file path=ppt/slides/slide17.xml><?xml version="1.0" encoding="utf-8"?>
-<p:sld xmlns:a="http://schemas.openxmlformats.org/drawingml/2006/main" xmlns:p="http://schemas.openxmlformats.org/presentationml/2006/main" xmlns:r="http://schemas.openxmlformats.org/officeDocument/2006/relationships">
-  <p:cSld>
-    <p:spTree>
-      <p:nvGrpSpPr>
-        <p:cNvPr id="1" name=""/>
-        <p:cNvGrpSpPr/>
-        <p:nvPr/>
-      </p:nvGrpSpPr>
-      <p:grpSpPr/>
-      <p:pic>
-        <p:nvPicPr>
-          <p:cNvPr id="2" name="Picture 1" descr="hi9.png"/>
-          <p:cNvPicPr>
-            <a:picLocks noChangeAspect="1"/>
-          </p:cNvPicPr>
-          <p:nvPr/>
-        </p:nvPicPr>
-        <p:blipFill>
-          <a:blip r:embed="rId2"/>
-          <a:stretch>
-            <a:fillRect/>
-          </a:stretch>
-        </p:blipFill>
-        <p:spPr>
-          <a:xfrm>
-            <a:off x="0" y="0"/>
-            <a:ext cx="18288000" cy="10287000"/>
-          </a:xfrm>
-          <a:prstGeom prst="rect">
-            <a:avLst/>
-          </a:prstGeom>
-        </p:spPr>
-      </p:pic>
-    </p:spTree>
-  </p:cSld>
-  <p:clrMapOvr>
-    <a:masterClrMapping/>
-  </p:clrMapOvr>
-</p:sld>
-</file>
-
-<file path=ppt/slides/slide18.xml><?xml version="1.0" encoding="utf-8"?>
-<p:sld xmlns:a="http://schemas.openxmlformats.org/drawingml/2006/main" xmlns:p="http://schemas.openxmlformats.org/presentationml/2006/main" xmlns:r="http://schemas.openxmlformats.org/officeDocument/2006/relationships">
-  <p:cSld>
-    <p:spTree>
-      <p:nvGrpSpPr>
-        <p:cNvPr id="1" name=""/>
-        <p:cNvGrpSpPr/>
-        <p:nvPr/>
-      </p:nvGrpSpPr>
-      <p:grpSpPr/>
-      <p:pic>
-        <p:nvPicPr>
-          <p:cNvPr id="2" name="Picture 1" descr="hi10.png"/>
-          <p:cNvPicPr>
-            <a:picLocks noChangeAspect="1"/>
-          </p:cNvPicPr>
-          <p:nvPr/>
-        </p:nvPicPr>
-        <p:blipFill>
-          <a:blip r:embed="rId2"/>
-          <a:stretch>
-            <a:fillRect/>
-          </a:stretch>
-        </p:blipFill>
-        <p:spPr>
-          <a:xfrm>
-            <a:off x="0" y="0"/>
-            <a:ext cx="18288000" cy="10287000"/>
-          </a:xfrm>
-          <a:prstGeom prst="rect">
-            <a:avLst/>
-          </a:prstGeom>
-        </p:spPr>
-      </p:pic>
-    </p:spTree>
-  </p:cSld>
-  <p:clrMapOvr>
-    <a:masterClrMapping/>
-  </p:clrMapOvr>
-</p:sld>
-</file>
-
-<file path=ppt/slides/slide19.xml><?xml version="1.0" encoding="utf-8"?>
-<p:sld xmlns:a="http://schemas.openxmlformats.org/drawingml/2006/main" xmlns:p="http://schemas.openxmlformats.org/presentationml/2006/main" xmlns:r="http://schemas.openxmlformats.org/officeDocument/2006/relationships">
-  <p:cSld>
-    <p:spTree>
-      <p:nvGrpSpPr>
-        <p:cNvPr id="1" name=""/>
-        <p:cNvGrpSpPr/>
-        <p:nvPr/>
-      </p:nvGrpSpPr>
-      <p:grpSpPr/>
-      <p:pic>
-        <p:nvPicPr>
-          <p:cNvPr id="2" name="Picture 1" descr="hi11.png"/>
-          <p:cNvPicPr>
-            <a:picLocks noChangeAspect="1"/>
-          </p:cNvPicPr>
-          <p:nvPr/>
-        </p:nvPicPr>
-        <p:blipFill>
-          <a:blip r:embed="rId2"/>
-          <a:stretch>
-            <a:fillRect/>
-          </a:stretch>
-        </p:blipFill>
-        <p:spPr>
-          <a:xfrm>
-            <a:off x="0" y="0"/>
-            <a:ext cx="18288000" cy="10287000"/>
-          </a:xfrm>
-          <a:prstGeom prst="rect">
-            <a:avLst/>
-          </a:prstGeom>
-        </p:spPr>
-      </p:pic>
     </p:spTree>
   </p:cSld>
   <p:clrMapOvr>
@@ -6681,6 +7113,392 @@
 </file>
 
 <file path=ppt/slides/slide20.xml><?xml version="1.0" encoding="utf-8"?>
+<p:sld xmlns:a="http://schemas.openxmlformats.org/drawingml/2006/main" xmlns:r="http://schemas.openxmlformats.org/officeDocument/2006/relationships" xmlns:p="http://schemas.openxmlformats.org/presentationml/2006/main">
+  <p:cSld name="Slide 14">
+    <p:bg>
+      <p:bgPr>
+        <a:solidFill>
+          <a:srgbClr val="07294D"/>
+        </a:solidFill>
+      </p:bgPr>
+    </p:bg>
+    <p:spTree>
+      <p:nvGrpSpPr>
+        <p:cNvPr id="1" name=""/>
+        <p:cNvGrpSpPr/>
+        <p:nvPr/>
+      </p:nvGrpSpPr>
+      <p:grpSpPr>
+        <a:xfrm>
+          <a:off x="0" y="0"/>
+          <a:ext cx="0" cy="0"/>
+          <a:chOff x="0" y="0"/>
+          <a:chExt cx="0" cy="0"/>
+        </a:xfrm>
+      </p:grpSpPr>
+      <p:sp>
+        <p:nvSpPr>
+          <p:cNvPr id="2" name="Shape 0"/>
+          <p:cNvSpPr/>
+          <p:nvPr/>
+        </p:nvSpPr>
+        <p:spPr>
+          <a:xfrm>
+            <a:off x="1028700" y="859536"/>
+            <a:ext cx="4480560" cy="1005840"/>
+          </a:xfrm>
+          <a:prstGeom prst="roundRect">
+            <a:avLst>
+              <a:gd name="adj" fmla="val 10909"/>
+            </a:avLst>
+          </a:prstGeom>
+          <a:solidFill>
+            <a:srgbClr val="FFFFFF"/>
+          </a:solidFill>
+          <a:ln/>
+        </p:spPr>
+      </p:sp>
+      <p:sp>
+        <p:nvSpPr>
+          <p:cNvPr id="3" name="Text 1"/>
+          <p:cNvSpPr txBox="1"/>
+          <p:nvPr/>
+        </p:nvSpPr>
+        <p:spPr>
+          <a:xfrm>
+            <a:off x="1339596" y="987552"/>
+            <a:ext cx="4023360" cy="384048"/>
+          </a:xfrm>
+          <a:prstGeom prst="rect">
+            <a:avLst/>
+          </a:prstGeom>
+          <a:noFill/>
+          <a:ln/>
+        </p:spPr>
+        <p:txBody>
+          <a:bodyPr wrap="square" lIns="0" tIns="0" rIns="0" bIns="0" rtlCol="0" anchor="t"/>
+          <a:lstStyle/>
+          <a:p>
+            <a:pPr indent="0" marL="0">
+              <a:buNone/>
+            </a:pPr>
+            <a:r>
+              <a:rPr lang="en-US" sz="2400" b="1" dirty="0">
+                <a:solidFill>
+                  <a:srgbClr val="07294D"/>
+                </a:solidFill>
+                <a:latin typeface="Georgia" pitchFamily="34" charset="0"/>
+                <a:ea typeface="Georgia" pitchFamily="34" charset="-122"/>
+                <a:cs typeface="Georgia" pitchFamily="34" charset="-120"/>
+              </a:rPr>
+              <a:t>Drexel University</a:t>
+            </a:r>
+            <a:endParaRPr lang="en-US" sz="2400" dirty="0"/>
+          </a:p>
+        </p:txBody>
+      </p:sp>
+      <p:sp>
+        <p:nvSpPr>
+          <p:cNvPr id="4" name="Text 2"/>
+          <p:cNvSpPr txBox="1"/>
+          <p:nvPr/>
+        </p:nvSpPr>
+        <p:spPr>
+          <a:xfrm>
+            <a:off x="1339596" y="1417320"/>
+            <a:ext cx="4023360" cy="310896"/>
+          </a:xfrm>
+          <a:prstGeom prst="rect">
+            <a:avLst/>
+          </a:prstGeom>
+          <a:noFill/>
+          <a:ln/>
+        </p:spPr>
+        <p:txBody>
+          <a:bodyPr wrap="square" lIns="0" tIns="0" rIns="0" bIns="0" rtlCol="0" anchor="t"/>
+          <a:lstStyle/>
+          <a:p>
+            <a:pPr indent="0" marL="0">
+              <a:buNone/>
+            </a:pPr>
+            <a:r>
+              <a:rPr lang="en-US" sz="1600" b="1" dirty="0">
+                <a:solidFill>
+                  <a:srgbClr val="006699"/>
+                </a:solidFill>
+                <a:latin typeface="Futura" pitchFamily="34" charset="0"/>
+                <a:ea typeface="Futura" pitchFamily="34" charset="-122"/>
+                <a:cs typeface="Futura" pitchFamily="34" charset="-120"/>
+              </a:rPr>
+              <a:t>Dornsife School of Public Health</a:t>
+            </a:r>
+            <a:endParaRPr lang="en-US" sz="1600" dirty="0"/>
+          </a:p>
+        </p:txBody>
+      </p:sp>
+      <p:sp>
+        <p:nvSpPr>
+          <p:cNvPr id="5" name="Text 3"/>
+          <p:cNvSpPr txBox="1"/>
+          <p:nvPr/>
+        </p:nvSpPr>
+        <p:spPr>
+          <a:xfrm>
+            <a:off x="1028700" y="4069080"/>
+            <a:ext cx="16230600" cy="274320"/>
+          </a:xfrm>
+          <a:prstGeom prst="rect">
+            <a:avLst/>
+          </a:prstGeom>
+          <a:noFill/>
+          <a:ln/>
+        </p:spPr>
+        <p:txBody>
+          <a:bodyPr wrap="square" lIns="0" tIns="0" rIns="0" bIns="0" rtlCol="0" anchor="t"/>
+          <a:lstStyle/>
+          <a:p>
+            <a:pPr indent="0" marL="0">
+              <a:buNone/>
+            </a:pPr>
+            <a:r>
+              <a:rPr lang="en-US" sz="1800" b="1" spc="300" kern="0" dirty="0">
+                <a:solidFill>
+                  <a:srgbClr val="FFC600"/>
+                </a:solidFill>
+                <a:latin typeface="Futura" pitchFamily="34" charset="0"/>
+                <a:ea typeface="Futura" pitchFamily="34" charset="-122"/>
+                <a:cs typeface="Futura" pitchFamily="34" charset="-120"/>
+              </a:rPr>
+              <a:t>THANK YOU</a:t>
+            </a:r>
+            <a:endParaRPr lang="en-US" sz="1800" dirty="0"/>
+          </a:p>
+        </p:txBody>
+      </p:sp>
+      <p:sp>
+        <p:nvSpPr>
+          <p:cNvPr id="6" name="Text 4"/>
+          <p:cNvSpPr txBox="1"/>
+          <p:nvPr/>
+        </p:nvSpPr>
+        <p:spPr>
+          <a:xfrm>
+            <a:off x="1028700" y="4434840"/>
+            <a:ext cx="16230600" cy="1371600"/>
+          </a:xfrm>
+          <a:prstGeom prst="rect">
+            <a:avLst/>
+          </a:prstGeom>
+          <a:noFill/>
+          <a:ln/>
+        </p:spPr>
+        <p:txBody>
+          <a:bodyPr wrap="square" lIns="0" tIns="0" rIns="0" bIns="0" rtlCol="0" anchor="ctr"/>
+          <a:lstStyle/>
+          <a:p>
+            <a:pPr indent="0" marL="0">
+              <a:buNone/>
+            </a:pPr>
+            <a:r>
+              <a:rPr lang="en-US" sz="8900" b="1" dirty="0">
+                <a:solidFill>
+                  <a:srgbClr val="FFFFFF"/>
+                </a:solidFill>
+                <a:latin typeface="Georgia" pitchFamily="34" charset="0"/>
+                <a:ea typeface="Georgia" pitchFamily="34" charset="-122"/>
+                <a:cs typeface="Georgia" pitchFamily="34" charset="-120"/>
+              </a:rPr>
+              <a:t>Questions &amp; Discussion</a:t>
+            </a:r>
+            <a:endParaRPr lang="en-US" sz="8900" dirty="0"/>
+          </a:p>
+        </p:txBody>
+      </p:sp>
+      <p:sp>
+        <p:nvSpPr>
+          <p:cNvPr id="7" name="Shape 5"/>
+          <p:cNvSpPr/>
+          <p:nvPr/>
+        </p:nvSpPr>
+        <p:spPr>
+          <a:xfrm>
+            <a:off x="1028700" y="6035040"/>
+            <a:ext cx="777240" cy="73152"/>
+          </a:xfrm>
+          <a:prstGeom prst="rect">
+            <a:avLst/>
+          </a:prstGeom>
+          <a:solidFill>
+            <a:srgbClr val="FFC600"/>
+          </a:solidFill>
+          <a:ln/>
+        </p:spPr>
+      </p:sp>
+      <p:sp>
+        <p:nvSpPr>
+          <p:cNvPr id="8" name="Text 6"/>
+          <p:cNvSpPr txBox="1"/>
+          <p:nvPr/>
+        </p:nvSpPr>
+        <p:spPr>
+          <a:xfrm>
+            <a:off x="1028700" y="6400800"/>
+            <a:ext cx="14173200" cy="914400"/>
+          </a:xfrm>
+          <a:prstGeom prst="rect">
+            <a:avLst/>
+          </a:prstGeom>
+          <a:noFill/>
+          <a:ln/>
+        </p:spPr>
+        <p:txBody>
+          <a:bodyPr wrap="square" lIns="0" tIns="0" rIns="0" bIns="0" rtlCol="0" anchor="t"/>
+          <a:lstStyle/>
+          <a:p>
+            <a:pPr indent="0" marL="0">
+              <a:buNone/>
+            </a:pPr>
+            <a:r>
+              <a:rPr lang="en-US" sz="2600" dirty="0">
+                <a:solidFill>
+                  <a:srgbClr val="C7D2DF"/>
+                </a:solidFill>
+                <a:latin typeface="Futura" pitchFamily="34" charset="0"/>
+                <a:ea typeface="Futura" pitchFamily="34" charset="-122"/>
+                <a:cs typeface="Futura" pitchFamily="34" charset="-120"/>
+              </a:rPr>
+              <a:t>Next: Core 2 — Workflow Enhancement. Use Copilot and ChatGPT Edu to speed up the work you already do.</a:t>
+            </a:r>
+            <a:endParaRPr lang="en-US" sz="2600" dirty="0"/>
+          </a:p>
+        </p:txBody>
+      </p:sp>
+      <p:sp>
+        <p:nvSpPr>
+          <p:cNvPr id="9" name="Text 7"/>
+          <p:cNvSpPr txBox="1"/>
+          <p:nvPr/>
+        </p:nvSpPr>
+        <p:spPr>
+          <a:xfrm>
+            <a:off x="1028700" y="8686800"/>
+            <a:ext cx="9144000" cy="365760"/>
+          </a:xfrm>
+          <a:prstGeom prst="rect">
+            <a:avLst/>
+          </a:prstGeom>
+          <a:noFill/>
+          <a:ln/>
+        </p:spPr>
+        <p:txBody>
+          <a:bodyPr wrap="square" lIns="0" tIns="0" rIns="0" bIns="0" rtlCol="0" anchor="t"/>
+          <a:lstStyle/>
+          <a:p>
+            <a:pPr indent="0" marL="0">
+              <a:buNone/>
+            </a:pPr>
+            <a:r>
+              <a:rPr lang="en-US" sz="2300" b="1" dirty="0">
+                <a:solidFill>
+                  <a:srgbClr val="FFFFFF"/>
+                </a:solidFill>
+                <a:latin typeface="Futura" pitchFamily="34" charset="0"/>
+                <a:ea typeface="Futura" pitchFamily="34" charset="-122"/>
+                <a:cs typeface="Futura" pitchFamily="34" charset="-120"/>
+              </a:rPr>
+              <a:t>Alex Quistberg, PhD, MPH</a:t>
+            </a:r>
+            <a:endParaRPr lang="en-US" sz="2300" dirty="0"/>
+          </a:p>
+        </p:txBody>
+      </p:sp>
+      <p:sp>
+        <p:nvSpPr>
+          <p:cNvPr id="10" name="Text 8"/>
+          <p:cNvSpPr txBox="1"/>
+          <p:nvPr/>
+        </p:nvSpPr>
+        <p:spPr>
+          <a:xfrm>
+            <a:off x="1028700" y="9070848"/>
+            <a:ext cx="10058400" cy="320040"/>
+          </a:xfrm>
+          <a:prstGeom prst="rect">
+            <a:avLst/>
+          </a:prstGeom>
+          <a:noFill/>
+          <a:ln/>
+        </p:spPr>
+        <p:txBody>
+          <a:bodyPr wrap="square" lIns="0" tIns="0" rIns="0" bIns="0" rtlCol="0" anchor="t"/>
+          <a:lstStyle/>
+          <a:p>
+            <a:pPr indent="0" marL="0">
+              <a:buNone/>
+            </a:pPr>
+            <a:r>
+              <a:rPr lang="en-US" sz="1900" dirty="0">
+                <a:solidFill>
+                  <a:srgbClr val="9FB3CC"/>
+                </a:solidFill>
+                <a:latin typeface="Futura" pitchFamily="34" charset="0"/>
+                <a:ea typeface="Futura" pitchFamily="34" charset="-122"/>
+                <a:cs typeface="Futura" pitchFamily="34" charset="-120"/>
+              </a:rPr>
+              <a:t>daq26@drexel.edu</a:t>
+            </a:r>
+            <a:endParaRPr lang="en-US" sz="1900" dirty="0"/>
+          </a:p>
+        </p:txBody>
+      </p:sp>
+      <p:sp>
+        <p:nvSpPr>
+          <p:cNvPr id="11" name="Text 9"/>
+          <p:cNvSpPr txBox="1"/>
+          <p:nvPr/>
+        </p:nvSpPr>
+        <p:spPr>
+          <a:xfrm>
+            <a:off x="9509760" y="9070848"/>
+            <a:ext cx="7772400" cy="320040"/>
+          </a:xfrm>
+          <a:prstGeom prst="rect">
+            <a:avLst/>
+          </a:prstGeom>
+          <a:noFill/>
+          <a:ln/>
+        </p:spPr>
+        <p:txBody>
+          <a:bodyPr wrap="square" lIns="0" tIns="0" rIns="0" bIns="0" rtlCol="0" anchor="t"/>
+          <a:lstStyle/>
+          <a:p>
+            <a:pPr algn="r" indent="0" marL="0">
+              <a:buNone/>
+            </a:pPr>
+            <a:r>
+              <a:rPr lang="en-US" sz="1900" dirty="0">
+                <a:solidFill>
+                  <a:srgbClr val="9FB3CC"/>
+                </a:solidFill>
+                <a:latin typeface="Futura" pitchFamily="34" charset="0"/>
+                <a:ea typeface="Futura" pitchFamily="34" charset="-122"/>
+                <a:cs typeface="Futura" pitchFamily="34" charset="-120"/>
+              </a:rPr>
+              <a:t>Department of Environmental &amp; Occupational Health</a:t>
+            </a:r>
+            <a:endParaRPr lang="en-US" sz="1900" dirty="0"/>
+          </a:p>
+        </p:txBody>
+      </p:sp>
+    </p:spTree>
+  </p:cSld>
+  <p:clrMapOvr>
+    <a:masterClrMapping/>
+  </p:clrMapOvr>
+</p:sld>
+</file>
+
+<file path=ppt/slides/slide21.xml><?xml version="1.0" encoding="utf-8"?>
 <p:sld xmlns:a="http://schemas.openxmlformats.org/drawingml/2006/main" xmlns:p="http://schemas.openxmlformats.org/presentationml/2006/main" xmlns:r="http://schemas.openxmlformats.org/officeDocument/2006/relationships">
   <p:cSld>
     <p:spTree>
@@ -8655,8 +9473,8 @@
 </file>
 
 <file path=ppt/slides/slide7.xml><?xml version="1.0" encoding="utf-8"?>
-<p:sld xmlns:a="http://schemas.openxmlformats.org/drawingml/2006/main" xmlns:r="http://schemas.openxmlformats.org/officeDocument/2006/relationships" xmlns:p="http://schemas.openxmlformats.org/presentationml/2006/main">
-  <p:cSld name="Slide 7">
+<p:sld xmlns:a="http://schemas.openxmlformats.org/drawingml/2006/main" xmlns:p="http://schemas.openxmlformats.org/presentationml/2006/main" xmlns:r="http://schemas.openxmlformats.org/officeDocument/2006/relationships">
+  <p:cSld>
     <p:bg>
       <p:bgPr>
         <a:solidFill>
@@ -8670,14 +9488,7 @@
         <p:cNvGrpSpPr/>
         <p:nvPr/>
       </p:nvGrpSpPr>
-      <p:grpSpPr>
-        <a:xfrm>
-          <a:off x="0" y="0"/>
-          <a:ext cx="0" cy="0"/>
-          <a:chOff x="0" y="0"/>
-          <a:chExt cx="0" cy="0"/>
-        </a:xfrm>
-      </p:grpSpPr>
+      <p:grpSpPr/>
       <p:sp>
         <p:nvSpPr>
           <p:cNvPr id="2" name="Text 0"/>
@@ -8711,7 +9522,7 @@
                 <a:ea typeface="Futura" pitchFamily="34" charset="-122"/>
                 <a:cs typeface="Futura" pitchFamily="34" charset="-120"/>
               </a:rPr>
-              <a:t>SECTION 03</a:t>
+              <a:t>SECTION 02</a:t>
             </a:r>
             <a:endParaRPr lang="en-US" sz="1800" dirty="0"/>
           </a:p>
@@ -8750,7 +9561,7 @@
                 <a:ea typeface="Georgia" pitchFamily="34" charset="-122"/>
                 <a:cs typeface="Georgia" pitchFamily="34" charset="-120"/>
               </a:rPr>
-              <a:t>How AI Gets Things Wrong</a:t>
+              <a:t>What It Can Do</a:t>
             </a:r>
             <a:endParaRPr lang="en-US" sz="7400" dirty="0"/>
           </a:p>
@@ -8813,7 +9624,7 @@
                 <a:ea typeface="Futura" pitchFamily="34" charset="-122"/>
                 <a:cs typeface="Futura" pitchFamily="34" charset="-120"/>
               </a:rPr>
-              <a:t>And who is responsible when it does.</a:t>
+              <a:t>Six real tasks from public health work: analyze data, review a draft, build slides, sort an inbox, find sources, form student groups, and one look past the chat box.</a:t>
             </a:r>
             <a:endParaRPr lang="en-US" sz="2800" dirty="0"/>
           </a:p>
@@ -8828,606 +9639,39 @@
 </file>
 
 <file path=ppt/slides/slide8.xml><?xml version="1.0" encoding="utf-8"?>
-<p:sld xmlns:a="http://schemas.openxmlformats.org/drawingml/2006/main" xmlns:r="http://schemas.openxmlformats.org/officeDocument/2006/relationships" xmlns:p="http://schemas.openxmlformats.org/presentationml/2006/main">
-  <p:cSld name="Slide 8">
-    <p:bg>
-      <p:bgPr>
-        <a:solidFill>
-          <a:srgbClr val="FFFFFF"/>
-        </a:solidFill>
-      </p:bgPr>
-    </p:bg>
+<p:sld xmlns:a="http://schemas.openxmlformats.org/drawingml/2006/main" xmlns:p="http://schemas.openxmlformats.org/presentationml/2006/main" xmlns:r="http://schemas.openxmlformats.org/officeDocument/2006/relationships">
+  <p:cSld>
     <p:spTree>
       <p:nvGrpSpPr>
         <p:cNvPr id="1" name=""/>
         <p:cNvGrpSpPr/>
         <p:nvPr/>
       </p:nvGrpSpPr>
-      <p:grpSpPr>
-        <a:xfrm>
-          <a:off x="0" y="0"/>
-          <a:ext cx="0" cy="0"/>
-          <a:chOff x="0" y="0"/>
-          <a:chExt cx="0" cy="0"/>
-        </a:xfrm>
-      </p:grpSpPr>
-      <p:sp>
-        <p:nvSpPr>
-          <p:cNvPr id="2" name="Text 0"/>
-          <p:cNvSpPr txBox="1"/>
-          <p:nvPr/>
-        </p:nvSpPr>
-        <p:spPr>
-          <a:xfrm>
-            <a:off x="1028700" y="868680"/>
-            <a:ext cx="16230600" cy="274320"/>
-          </a:xfrm>
-          <a:prstGeom prst="rect">
-            <a:avLst/>
-          </a:prstGeom>
-          <a:noFill/>
-          <a:ln/>
-        </p:spPr>
-        <p:txBody>
-          <a:bodyPr wrap="square" lIns="0" tIns="0" rIns="0" bIns="0" rtlCol="0" anchor="t"/>
-          <a:lstStyle/>
-          <a:p>
-            <a:pPr indent="0" marL="0">
-              <a:buNone/>
-            </a:pPr>
-            <a:r>
-              <a:rPr lang="en-US" sz="1800" b="1" spc="300" kern="0" dirty="0">
-                <a:solidFill>
-                  <a:srgbClr val="006699"/>
-                </a:solidFill>
-                <a:latin typeface="Futura" pitchFamily="34" charset="0"/>
-                <a:ea typeface="Futura" pitchFamily="34" charset="-122"/>
-                <a:cs typeface="Futura" pitchFamily="34" charset="-120"/>
-              </a:rPr>
-              <a:t>THREE THINGS TO REMEMBER</a:t>
-            </a:r>
-            <a:endParaRPr lang="en-US" sz="1800" dirty="0"/>
-          </a:p>
-        </p:txBody>
-      </p:sp>
-      <p:sp>
-        <p:nvSpPr>
-          <p:cNvPr id="3" name="Text 1"/>
-          <p:cNvSpPr txBox="1"/>
-          <p:nvPr/>
-        </p:nvSpPr>
-        <p:spPr>
-          <a:xfrm>
-            <a:off x="1028700" y="1188720"/>
-            <a:ext cx="16230600" cy="822960"/>
-          </a:xfrm>
-          <a:prstGeom prst="rect">
-            <a:avLst/>
-          </a:prstGeom>
-          <a:noFill/>
-          <a:ln/>
-        </p:spPr>
-        <p:txBody>
-          <a:bodyPr wrap="square" lIns="0" tIns="0" rIns="0" bIns="0" rtlCol="0" anchor="ctr"/>
-          <a:lstStyle/>
-          <a:p>
-            <a:pPr indent="0" marL="0">
-              <a:buNone/>
-            </a:pPr>
-            <a:r>
-              <a:rPr lang="en-US" sz="5500" b="1" dirty="0">
-                <a:solidFill>
-                  <a:srgbClr val="07294D"/>
-                </a:solidFill>
-                <a:latin typeface="Georgia" pitchFamily="34" charset="0"/>
-                <a:ea typeface="Georgia" pitchFamily="34" charset="-122"/>
-                <a:cs typeface="Georgia" pitchFamily="34" charset="-120"/>
-              </a:rPr>
-              <a:t>Wrong, Biased, and Yours</a:t>
-            </a:r>
-            <a:endParaRPr lang="en-US" sz="5500" dirty="0"/>
-          </a:p>
-        </p:txBody>
-      </p:sp>
-      <p:sp>
-        <p:nvSpPr>
-          <p:cNvPr id="4" name="Shape 2"/>
-          <p:cNvSpPr/>
-          <p:nvPr/>
-        </p:nvSpPr>
-        <p:spPr>
-          <a:xfrm>
-            <a:off x="1028700" y="2103120"/>
-            <a:ext cx="777240" cy="73152"/>
-          </a:xfrm>
-          <a:prstGeom prst="rect">
-            <a:avLst/>
-          </a:prstGeom>
-          <a:solidFill>
-            <a:srgbClr val="FFC600"/>
-          </a:solidFill>
-          <a:ln/>
-        </p:spPr>
-      </p:sp>
-      <p:sp>
-        <p:nvSpPr>
-          <p:cNvPr id="5" name="Shape 3"/>
-          <p:cNvSpPr/>
-          <p:nvPr/>
-        </p:nvSpPr>
-        <p:spPr>
-          <a:xfrm>
-            <a:off x="1028700" y="9646920"/>
-            <a:ext cx="16230600" cy="0"/>
-          </a:xfrm>
-          <a:prstGeom prst="line">
-            <a:avLst/>
-          </a:prstGeom>
-          <a:noFill/>
-          <a:ln w="9525">
-            <a:solidFill>
-              <a:srgbClr val="D0D3D4"/>
-            </a:solidFill>
-            <a:prstDash val="solid"/>
-          </a:ln>
-        </p:spPr>
-      </p:sp>
-      <p:sp>
-        <p:nvSpPr>
-          <p:cNvPr id="6" name="Text 4"/>
-          <p:cNvSpPr txBox="1"/>
-          <p:nvPr/>
-        </p:nvSpPr>
-        <p:spPr>
-          <a:xfrm>
-            <a:off x="1028700" y="9784080"/>
-            <a:ext cx="7315200" cy="274320"/>
-          </a:xfrm>
-          <a:prstGeom prst="rect">
-            <a:avLst/>
-          </a:prstGeom>
-          <a:noFill/>
-          <a:ln/>
-        </p:spPr>
-        <p:txBody>
-          <a:bodyPr wrap="square" lIns="0" tIns="0" rIns="0" bIns="0" rtlCol="0" anchor="t"/>
-          <a:lstStyle/>
-          <a:p>
-            <a:pPr indent="0" marL="0">
-              <a:buNone/>
-            </a:pPr>
-            <a:r>
-              <a:rPr lang="en-US" sz="1400" b="1" dirty="0">
-                <a:solidFill>
-                  <a:srgbClr val="07294D"/>
-                </a:solidFill>
-                <a:latin typeface="Futura" pitchFamily="34" charset="0"/>
-                <a:ea typeface="Futura" pitchFamily="34" charset="-122"/>
-                <a:cs typeface="Futura" pitchFamily="34" charset="-120"/>
-              </a:rPr>
-              <a:t>Environmental &amp; Occupational Health</a:t>
-            </a:r>
-            <a:endParaRPr lang="en-US" sz="1400" dirty="0"/>
-          </a:p>
-        </p:txBody>
-      </p:sp>
-      <p:sp>
-        <p:nvSpPr>
-          <p:cNvPr id="7" name="Text 5"/>
-          <p:cNvSpPr txBox="1"/>
-          <p:nvPr/>
-        </p:nvSpPr>
-        <p:spPr>
-          <a:xfrm>
-            <a:off x="9944100" y="9784080"/>
-            <a:ext cx="7315200" cy="274320"/>
-          </a:xfrm>
-          <a:prstGeom prst="rect">
-            <a:avLst/>
-          </a:prstGeom>
-          <a:noFill/>
-          <a:ln/>
-        </p:spPr>
-        <p:txBody>
-          <a:bodyPr wrap="square" lIns="0" tIns="0" rIns="0" bIns="0" rtlCol="0" anchor="t"/>
-          <a:lstStyle/>
-          <a:p>
-            <a:pPr algn="r" indent="0" marL="0">
-              <a:buNone/>
-            </a:pPr>
-            <a:r>
-              <a:rPr lang="en-US" sz="1400" dirty="0">
-                <a:solidFill>
-                  <a:srgbClr val="5A6571"/>
-                </a:solidFill>
-                <a:latin typeface="Futura" pitchFamily="34" charset="0"/>
-                <a:ea typeface="Futura" pitchFamily="34" charset="-122"/>
-                <a:cs typeface="Futura" pitchFamily="34" charset="-120"/>
-              </a:rPr>
-              <a:t>Dornsife School of Public Health</a:t>
-            </a:r>
-            <a:endParaRPr lang="en-US" sz="1400" dirty="0"/>
-          </a:p>
-        </p:txBody>
-      </p:sp>
-      <p:sp>
-        <p:nvSpPr>
-          <p:cNvPr id="9" name="Shape 6"/>
-          <p:cNvSpPr/>
-          <p:nvPr/>
-        </p:nvSpPr>
-        <p:spPr>
-          <a:xfrm>
-            <a:off x="1028700" y="2697480"/>
-            <a:ext cx="5029200" cy="4206240"/>
-          </a:xfrm>
-          <a:prstGeom prst="rect">
-            <a:avLst/>
-          </a:prstGeom>
-          <a:solidFill>
-            <a:srgbClr val="FFFFFF"/>
-          </a:solidFill>
-          <a:ln w="9525">
-            <a:solidFill>
-              <a:srgbClr val="D0D3D4"/>
-            </a:solidFill>
-            <a:prstDash val="solid"/>
-          </a:ln>
-        </p:spPr>
-      </p:sp>
-      <p:sp>
-        <p:nvSpPr>
-          <p:cNvPr id="10" name="Shape 7"/>
-          <p:cNvSpPr/>
-          <p:nvPr/>
-        </p:nvSpPr>
-        <p:spPr>
-          <a:xfrm>
-            <a:off x="1028700" y="2697480"/>
-            <a:ext cx="5029200" cy="91440"/>
-          </a:xfrm>
-          <a:prstGeom prst="rect">
-            <a:avLst/>
-          </a:prstGeom>
-          <a:solidFill>
-            <a:srgbClr val="07294D"/>
-          </a:solidFill>
-          <a:ln/>
-        </p:spPr>
-      </p:sp>
-      <p:sp>
-        <p:nvSpPr>
-          <p:cNvPr id="11" name="Text 8"/>
-          <p:cNvSpPr txBox="1"/>
-          <p:nvPr/>
-        </p:nvSpPr>
-        <p:spPr>
-          <a:xfrm>
-            <a:off x="1394460" y="3108960"/>
-            <a:ext cx="4297680" cy="548640"/>
-          </a:xfrm>
-          <a:prstGeom prst="rect">
-            <a:avLst/>
-          </a:prstGeom>
-          <a:noFill/>
-          <a:ln/>
-        </p:spPr>
-        <p:txBody>
-          <a:bodyPr wrap="square" lIns="0" tIns="0" rIns="0" bIns="0" rtlCol="0" anchor="t"/>
-          <a:lstStyle/>
-          <a:p>
-            <a:pPr indent="0" marL="0">
-              <a:buNone/>
-            </a:pPr>
-            <a:r>
-              <a:rPr lang="en-US" sz="3100" b="1" dirty="0">
-                <a:solidFill>
-                  <a:srgbClr val="07294D"/>
-                </a:solidFill>
-                <a:latin typeface="Georgia" pitchFamily="34" charset="0"/>
-                <a:ea typeface="Georgia" pitchFamily="34" charset="-122"/>
-                <a:cs typeface="Georgia" pitchFamily="34" charset="-120"/>
-              </a:rPr>
-              <a:t>It Makes Things Up</a:t>
-            </a:r>
-            <a:endParaRPr lang="en-US" sz="3100" dirty="0"/>
-          </a:p>
-        </p:txBody>
-      </p:sp>
-      <p:sp>
-        <p:nvSpPr>
-          <p:cNvPr id="12" name="Text 9"/>
-          <p:cNvSpPr txBox="1"/>
-          <p:nvPr/>
-        </p:nvSpPr>
-        <p:spPr>
-          <a:xfrm>
-            <a:off x="1394460" y="3840480"/>
-            <a:ext cx="4297680" cy="2743200"/>
-          </a:xfrm>
-          <a:prstGeom prst="rect">
-            <a:avLst/>
-          </a:prstGeom>
-          <a:noFill/>
-          <a:ln/>
-        </p:spPr>
-        <p:txBody>
-          <a:bodyPr wrap="square" lIns="0" tIns="0" rIns="0" bIns="0" rtlCol="0" anchor="t"/>
-          <a:lstStyle/>
-          <a:p>
-            <a:pPr indent="0" marL="0">
-              <a:lnSpc>
-                <a:spcPct val="125000"/>
-              </a:lnSpc>
-              <a:buNone/>
-            </a:pPr>
-            <a:r>
-              <a:rPr lang="en-US" sz="2300" dirty="0">
-                <a:solidFill>
-                  <a:srgbClr val="5A6571"/>
-                </a:solidFill>
-                <a:latin typeface="Futura" pitchFamily="34" charset="0"/>
-                <a:ea typeface="Futura" pitchFamily="34" charset="-122"/>
-                <a:cs typeface="Futura" pitchFamily="34" charset="-120"/>
-              </a:rPr>
-              <a:t>It predicts likely-sounding text, so it can invent facts, numbers, and citations. Check anything that matters.</a:t>
-            </a:r>
-            <a:endParaRPr lang="en-US" sz="2300" dirty="0"/>
-          </a:p>
-        </p:txBody>
-      </p:sp>
-      <p:sp>
-        <p:nvSpPr>
-          <p:cNvPr id="13" name="Shape 10"/>
-          <p:cNvSpPr/>
-          <p:nvPr/>
-        </p:nvSpPr>
-        <p:spPr>
-          <a:xfrm>
-            <a:off x="6629400" y="2697480"/>
-            <a:ext cx="5029200" cy="4206240"/>
-          </a:xfrm>
-          <a:prstGeom prst="rect">
-            <a:avLst/>
-          </a:prstGeom>
-          <a:solidFill>
-            <a:srgbClr val="FFFFFF"/>
-          </a:solidFill>
-          <a:ln w="9525">
-            <a:solidFill>
-              <a:srgbClr val="D0D3D4"/>
-            </a:solidFill>
-            <a:prstDash val="solid"/>
-          </a:ln>
-        </p:spPr>
-      </p:sp>
-      <p:sp>
-        <p:nvSpPr>
-          <p:cNvPr id="14" name="Shape 11"/>
-          <p:cNvSpPr/>
-          <p:nvPr/>
-        </p:nvSpPr>
-        <p:spPr>
-          <a:xfrm>
-            <a:off x="6629400" y="2697480"/>
-            <a:ext cx="5029200" cy="91440"/>
-          </a:xfrm>
-          <a:prstGeom prst="rect">
-            <a:avLst/>
-          </a:prstGeom>
-          <a:solidFill>
-            <a:srgbClr val="006699"/>
-          </a:solidFill>
-          <a:ln/>
-        </p:spPr>
-      </p:sp>
-      <p:sp>
-        <p:nvSpPr>
-          <p:cNvPr id="15" name="Text 12"/>
-          <p:cNvSpPr txBox="1"/>
-          <p:nvPr/>
-        </p:nvSpPr>
-        <p:spPr>
-          <a:xfrm>
-            <a:off x="6995160" y="3108960"/>
-            <a:ext cx="4297680" cy="548640"/>
-          </a:xfrm>
-          <a:prstGeom prst="rect">
-            <a:avLst/>
-          </a:prstGeom>
-          <a:noFill/>
-          <a:ln/>
-        </p:spPr>
-        <p:txBody>
-          <a:bodyPr wrap="square" lIns="0" tIns="0" rIns="0" bIns="0" rtlCol="0" anchor="t"/>
-          <a:lstStyle/>
-          <a:p>
-            <a:pPr indent="0" marL="0">
-              <a:buNone/>
-            </a:pPr>
-            <a:r>
-              <a:rPr lang="en-US" sz="3100" b="1" dirty="0">
-                <a:solidFill>
-                  <a:srgbClr val="07294D"/>
-                </a:solidFill>
-                <a:latin typeface="Georgia" pitchFamily="34" charset="0"/>
-                <a:ea typeface="Georgia" pitchFamily="34" charset="-122"/>
-                <a:cs typeface="Georgia" pitchFamily="34" charset="-120"/>
-              </a:rPr>
-              <a:t>It Can Be Biased</a:t>
-            </a:r>
-            <a:endParaRPr lang="en-US" sz="3100" dirty="0"/>
-          </a:p>
-        </p:txBody>
-      </p:sp>
-      <p:sp>
-        <p:nvSpPr>
-          <p:cNvPr id="16" name="Text 13"/>
-          <p:cNvSpPr txBox="1"/>
-          <p:nvPr/>
-        </p:nvSpPr>
-        <p:spPr>
-          <a:xfrm>
-            <a:off x="6995160" y="3840480"/>
-            <a:ext cx="4297680" cy="2743200"/>
-          </a:xfrm>
-          <a:prstGeom prst="rect">
-            <a:avLst/>
-          </a:prstGeom>
-          <a:noFill/>
-          <a:ln/>
-        </p:spPr>
-        <p:txBody>
-          <a:bodyPr wrap="square" lIns="0" tIns="0" rIns="0" bIns="0" rtlCol="0" anchor="t"/>
-          <a:lstStyle/>
-          <a:p>
-            <a:pPr indent="0" marL="0">
-              <a:lnSpc>
-                <a:spcPct val="125000"/>
-              </a:lnSpc>
-              <a:buNone/>
-            </a:pPr>
-            <a:r>
-              <a:rPr lang="en-US" sz="2300" dirty="0">
-                <a:solidFill>
-                  <a:srgbClr val="5A6571"/>
-                </a:solidFill>
-                <a:latin typeface="Futura" pitchFamily="34" charset="0"/>
-                <a:ea typeface="Futura" pitchFamily="34" charset="-122"/>
-                <a:cs typeface="Futura" pitchFamily="34" charset="-120"/>
-              </a:rPr>
-              <a:t>It learned from writing that reflects society's inequities, so answers can repeat stereotypes. Our work affects real communities.</a:t>
-            </a:r>
-            <a:endParaRPr lang="en-US" sz="2300" dirty="0"/>
-          </a:p>
-        </p:txBody>
-      </p:sp>
-      <p:sp>
-        <p:nvSpPr>
-          <p:cNvPr id="17" name="Shape 14"/>
-          <p:cNvSpPr/>
-          <p:nvPr/>
-        </p:nvSpPr>
-        <p:spPr>
-          <a:xfrm>
-            <a:off x="12230100" y="2697480"/>
-            <a:ext cx="5029200" cy="4206240"/>
-          </a:xfrm>
-          <a:prstGeom prst="rect">
-            <a:avLst/>
-          </a:prstGeom>
-          <a:solidFill>
-            <a:srgbClr val="FFFFFF"/>
-          </a:solidFill>
-          <a:ln w="9525">
-            <a:solidFill>
-              <a:srgbClr val="D0D3D4"/>
-            </a:solidFill>
-            <a:prstDash val="solid"/>
-          </a:ln>
-        </p:spPr>
-      </p:sp>
-      <p:sp>
-        <p:nvSpPr>
-          <p:cNvPr id="18" name="Shape 15"/>
-          <p:cNvSpPr/>
-          <p:nvPr/>
-        </p:nvSpPr>
-        <p:spPr>
-          <a:xfrm>
-            <a:off x="12230100" y="2697480"/>
-            <a:ext cx="5029200" cy="91440"/>
-          </a:xfrm>
-          <a:prstGeom prst="rect">
-            <a:avLst/>
-          </a:prstGeom>
-          <a:solidFill>
-            <a:srgbClr val="FFC600"/>
-          </a:solidFill>
-          <a:ln/>
-        </p:spPr>
-      </p:sp>
-      <p:sp>
-        <p:nvSpPr>
-          <p:cNvPr id="19" name="Text 16"/>
-          <p:cNvSpPr txBox="1"/>
-          <p:nvPr/>
-        </p:nvSpPr>
-        <p:spPr>
-          <a:xfrm>
-            <a:off x="12595860" y="3108960"/>
-            <a:ext cx="4297680" cy="548640"/>
-          </a:xfrm>
-          <a:prstGeom prst="rect">
-            <a:avLst/>
-          </a:prstGeom>
-          <a:noFill/>
-          <a:ln/>
-        </p:spPr>
-        <p:txBody>
-          <a:bodyPr wrap="square" lIns="0" tIns="0" rIns="0" bIns="0" rtlCol="0" anchor="t"/>
-          <a:lstStyle/>
-          <a:p>
-            <a:pPr indent="0" marL="0">
-              <a:buNone/>
-            </a:pPr>
-            <a:r>
-              <a:rPr lang="en-US" sz="3100" b="1" dirty="0">
-                <a:solidFill>
-                  <a:srgbClr val="07294D"/>
-                </a:solidFill>
-                <a:latin typeface="Georgia" pitchFamily="34" charset="0"/>
-                <a:ea typeface="Georgia" pitchFamily="34" charset="-122"/>
-                <a:cs typeface="Georgia" pitchFamily="34" charset="-120"/>
-              </a:rPr>
-              <a:t>You Are Responsible</a:t>
-            </a:r>
-            <a:endParaRPr lang="en-US" sz="3100" dirty="0"/>
-          </a:p>
-        </p:txBody>
-      </p:sp>
-      <p:sp>
-        <p:nvSpPr>
-          <p:cNvPr id="20" name="Text 17"/>
-          <p:cNvSpPr txBox="1"/>
-          <p:nvPr/>
-        </p:nvSpPr>
-        <p:spPr>
-          <a:xfrm>
-            <a:off x="12595860" y="3840480"/>
-            <a:ext cx="4297680" cy="2743200"/>
-          </a:xfrm>
-          <a:prstGeom prst="rect">
-            <a:avLst/>
-          </a:prstGeom>
-          <a:noFill/>
-          <a:ln/>
-        </p:spPr>
-        <p:txBody>
-          <a:bodyPr wrap="square" lIns="0" tIns="0" rIns="0" bIns="0" rtlCol="0" anchor="t"/>
-          <a:lstStyle/>
-          <a:p>
-            <a:pPr indent="0" marL="0">
-              <a:lnSpc>
-                <a:spcPct val="125000"/>
-              </a:lnSpc>
-              <a:buNone/>
-            </a:pPr>
-            <a:r>
-              <a:rPr lang="en-US" sz="2300" dirty="0">
-                <a:solidFill>
-                  <a:srgbClr val="5A6571"/>
-                </a:solidFill>
-                <a:latin typeface="Futura" pitchFamily="34" charset="0"/>
-                <a:ea typeface="Futura" pitchFamily="34" charset="-122"/>
-                <a:cs typeface="Futura" pitchFamily="34" charset="-120"/>
-              </a:rPr>
-              <a:t>If your name is on it, you own it: accuracy, fairness, and tone. “The AI wrote it” is never the answer.</a:t>
-            </a:r>
-            <a:endParaRPr lang="en-US" sz="2300" dirty="0"/>
-          </a:p>
-        </p:txBody>
-      </p:sp>
+      <p:grpSpPr/>
+      <p:pic>
+        <p:nvPicPr>
+          <p:cNvPr id="2" name="Picture 1" descr="hi8.png"/>
+          <p:cNvPicPr>
+            <a:picLocks noChangeAspect="1"/>
+          </p:cNvPicPr>
+          <p:nvPr/>
+        </p:nvPicPr>
+        <p:blipFill>
+          <a:blip r:embed="rId2"/>
+          <a:stretch>
+            <a:fillRect/>
+          </a:stretch>
+        </p:blipFill>
+        <p:spPr>
+          <a:xfrm>
+            <a:off x="0" y="0"/>
+            <a:ext cx="18288000" cy="10287000"/>
+          </a:xfrm>
+          <a:prstGeom prst="rect">
+            <a:avLst/>
+          </a:prstGeom>
+        </p:spPr>
+      </p:pic>
     </p:spTree>
   </p:cSld>
   <p:clrMapOvr>
@@ -9437,170 +9681,39 @@
 </file>
 
 <file path=ppt/slides/slide9.xml><?xml version="1.0" encoding="utf-8"?>
-<p:sld xmlns:a="http://schemas.openxmlformats.org/drawingml/2006/main" xmlns:r="http://schemas.openxmlformats.org/officeDocument/2006/relationships" xmlns:p="http://schemas.openxmlformats.org/presentationml/2006/main">
-  <p:cSld name="Slide 9">
-    <p:bg>
-      <p:bgPr>
-        <a:solidFill>
-          <a:srgbClr val="07294D"/>
-        </a:solidFill>
-      </p:bgPr>
-    </p:bg>
+<p:sld xmlns:a="http://schemas.openxmlformats.org/drawingml/2006/main" xmlns:p="http://schemas.openxmlformats.org/presentationml/2006/main" xmlns:r="http://schemas.openxmlformats.org/officeDocument/2006/relationships">
+  <p:cSld>
     <p:spTree>
       <p:nvGrpSpPr>
         <p:cNvPr id="1" name=""/>
         <p:cNvGrpSpPr/>
         <p:nvPr/>
       </p:nvGrpSpPr>
-      <p:grpSpPr>
-        <a:xfrm>
-          <a:off x="0" y="0"/>
-          <a:ext cx="0" cy="0"/>
-          <a:chOff x="0" y="0"/>
-          <a:chExt cx="0" cy="0"/>
-        </a:xfrm>
-      </p:grpSpPr>
-      <p:sp>
-        <p:nvSpPr>
-          <p:cNvPr id="2" name="Text 0"/>
-          <p:cNvSpPr txBox="1"/>
-          <p:nvPr/>
-        </p:nvSpPr>
-        <p:spPr>
-          <a:xfrm>
-            <a:off x="1028700" y="3383280"/>
-            <a:ext cx="16230600" cy="274320"/>
-          </a:xfrm>
-          <a:prstGeom prst="rect">
-            <a:avLst/>
-          </a:prstGeom>
-          <a:noFill/>
-          <a:ln/>
-        </p:spPr>
-        <p:txBody>
-          <a:bodyPr wrap="square" lIns="0" tIns="0" rIns="0" bIns="0" rtlCol="0" anchor="t"/>
-          <a:lstStyle/>
-          <a:p>
-            <a:pPr indent="0" marL="0">
-              <a:buNone/>
-            </a:pPr>
-            <a:r>
-              <a:rPr lang="en-US" sz="1800" b="1" spc="300" kern="0" dirty="0">
-                <a:solidFill>
-                  <a:srgbClr val="FFC600"/>
-                </a:solidFill>
-                <a:latin typeface="Futura" pitchFamily="34" charset="0"/>
-                <a:ea typeface="Futura" pitchFamily="34" charset="-122"/>
-                <a:cs typeface="Futura" pitchFamily="34" charset="-120"/>
-              </a:rPr>
-              <a:t>SECTION 04</a:t>
-            </a:r>
-            <a:endParaRPr lang="en-US" sz="1800" dirty="0"/>
-          </a:p>
-        </p:txBody>
-      </p:sp>
-      <p:sp>
-        <p:nvSpPr>
-          <p:cNvPr id="3" name="Text 1"/>
-          <p:cNvSpPr txBox="1"/>
-          <p:nvPr/>
-        </p:nvSpPr>
-        <p:spPr>
-          <a:xfrm>
-            <a:off x="1028700" y="3749040"/>
-            <a:ext cx="16230600" cy="1097280"/>
-          </a:xfrm>
-          <a:prstGeom prst="rect">
-            <a:avLst/>
-          </a:prstGeom>
-          <a:noFill/>
-          <a:ln/>
-        </p:spPr>
-        <p:txBody>
-          <a:bodyPr wrap="square" lIns="0" tIns="0" rIns="0" bIns="0" rtlCol="0" anchor="ctr"/>
-          <a:lstStyle/>
-          <a:p>
-            <a:pPr indent="0" marL="0">
-              <a:buNone/>
-            </a:pPr>
-            <a:r>
-              <a:rPr lang="en-US" sz="7400" b="1" dirty="0">
-                <a:solidFill>
-                  <a:srgbClr val="FFFFFF"/>
-                </a:solidFill>
-                <a:latin typeface="Georgia" pitchFamily="34" charset="0"/>
-                <a:ea typeface="Georgia" pitchFamily="34" charset="-122"/>
-                <a:cs typeface="Georgia" pitchFamily="34" charset="-120"/>
-              </a:rPr>
-              <a:t>Hands-On</a:t>
-            </a:r>
-            <a:endParaRPr lang="en-US" sz="7400" dirty="0"/>
-          </a:p>
-        </p:txBody>
-      </p:sp>
-      <p:sp>
-        <p:nvSpPr>
-          <p:cNvPr id="4" name="Shape 2"/>
-          <p:cNvSpPr/>
-          <p:nvPr/>
-        </p:nvSpPr>
-        <p:spPr>
-          <a:xfrm>
-            <a:off x="1028700" y="5074920"/>
-            <a:ext cx="777240" cy="73152"/>
-          </a:xfrm>
-          <a:prstGeom prst="rect">
-            <a:avLst/>
-          </a:prstGeom>
-          <a:solidFill>
-            <a:srgbClr val="FFC600"/>
-          </a:solidFill>
-          <a:ln/>
-        </p:spPr>
-        <p:txBody>
-          <a:bodyPr/>
-          <a:p/>
-        </p:txBody>
-      </p:sp>
-      <p:sp>
-        <p:nvSpPr>
-          <p:cNvPr id="5" name="Text 3"/>
-          <p:cNvSpPr txBox="1"/>
-          <p:nvPr/>
-        </p:nvSpPr>
-        <p:spPr>
-          <a:xfrm>
-            <a:off x="1028700" y="5486400"/>
-            <a:ext cx="13258800" cy="914400"/>
-          </a:xfrm>
-          <a:prstGeom prst="rect">
-            <a:avLst/>
-          </a:prstGeom>
-          <a:noFill/>
-          <a:ln/>
-        </p:spPr>
-        <p:txBody>
-          <a:bodyPr wrap="square" lIns="0" tIns="0" rIns="0" bIns="0" rtlCol="0" anchor="t"/>
-          <a:lstStyle/>
-          <a:p>
-            <a:pPr indent="0" marL="0">
-              <a:buNone/>
-            </a:pPr>
-            <a:r>
-              <a:rPr lang="en-US" sz="2800" dirty="0">
-                <a:solidFill>
-                  <a:srgbClr val="C7D2DF"/>
-                </a:solidFill>
-                <a:latin typeface="Futura" pitchFamily="34" charset="0"/>
-                <a:ea typeface="Futura" pitchFamily="34" charset="-122"/>
-                <a:cs typeface="Futura" pitchFamily="34" charset="-120"/>
-              </a:rPr>
-              <a:t>A guided tour, three first requests, and a simple recipe for better answers.</a:t>
-            </a:r>
-            <a:endParaRPr lang="en-US" sz="2800" dirty="0"/>
-          </a:p>
-        </p:txBody>
-      </p:sp>
+      <p:grpSpPr/>
+      <p:pic>
+        <p:nvPicPr>
+          <p:cNvPr id="2" name="Picture 1" descr="hi9.png"/>
+          <p:cNvPicPr>
+            <a:picLocks noChangeAspect="1"/>
+          </p:cNvPicPr>
+          <p:nvPr/>
+        </p:nvPicPr>
+        <p:blipFill>
+          <a:blip r:embed="rId2"/>
+          <a:stretch>
+            <a:fillRect/>
+          </a:stretch>
+        </p:blipFill>
+        <p:spPr>
+          <a:xfrm>
+            <a:off x="0" y="0"/>
+            <a:ext cx="18288000" cy="10287000"/>
+          </a:xfrm>
+          <a:prstGeom prst="rect">
+            <a:avLst/>
+          </a:prstGeom>
+        </p:spPr>
+      </p:pic>
     </p:spTree>
   </p:cSld>
   <p:clrMapOvr>

</xml_diff>

<commit_message>
All sessions on Zoom; add 'second AI as reviewer' model
- Core 1: page, slides, PowerPoint notes, and guide converted to Zoom
  (shared screen, reactions, chat); closing slide points to new Core 2
- Cores 3-4, electives, and home page: in-person cues replaced; Core 4
  disclosure trade now uses two-person breakout rooms or chat
- Core 4: 'Looking Ahead: A Second AI as Reviewer' box modeled on
  Anthropic's Code Review (find, verify, rank, people decide), with a
  fresh-chat review prompt; linked from Core 2
- How I Use AI page: 'Where This Is Heading' section

Co-Authored-By: Claude Opus 5.5 <noreply@anthropic.com>
</commit_message>
<xml_diff>
--- a/docs/slides/DSPH_Workshop1_Foundations_and_Capabilities.pptx
+++ b/docs/slides/DSPH_Workshop1_Foundations_and_Capabilities.pptx
@@ -610,7 +610,7 @@
           <a:p>
             <a:r>
               <a:rPr lang="en-US" dirty="0"/>
-              <a:t>Do each step on the projector and pause. Ask people to give a thumbs-up when they have finished a step. Steps 4 and 6 teach the most important idea: a chat remembers earlier messages, and a new chat starts fresh. Backup if sign-in fails: Copilot Chat with a Drexel account, or pair with a neighbor.</a:t>
+              <a:t>Do each step on your shared screen and pause. Ask people to react with a thumbs-up in Zoom when they have finished a step. Steps 4 and 6 teach the most important idea: a chat remembers earlier messages, and a new chat starts fresh. Backup if sign-in fails: Copilot Chat with a Drexel account. Ask people who are stuck to say so in the chat.</a:t>
             </a:r>
             <a:endParaRPr lang="en-US" dirty="0"/>
           </a:p>
@@ -786,7 +786,7 @@
           <a:p>
             <a:r>
               <a:rPr lang="en-US" dirty="0"/>
-              <a:t>Run the short prompt and the full prompt on the projector so the room sees the difference. Then ask everyone to write a PTCF prompt for a real email or short document they need this week, using made-up names and details. You don't need all four parts every time; adding even one or two helps. Ask two or three people which answer they would send.</a:t>
+              <a:t>Run the short prompt and the full prompt on your shared screen so everyone sees the difference. Then ask everyone to write a PTCF prompt for a real email or short document they need this week, using made-up names and details. You don't need all four parts every time; adding even one or two helps. Ask people to paste their prompt in the Zoom chat, and read two or three aloud.</a:t>
             </a:r>
             <a:endParaRPr lang="en-US" dirty="0"/>
           </a:p>
@@ -2933,7 +2933,7 @@
                 <a:ea typeface="Futura" pitchFamily="34" charset="-122"/>
                 <a:cs typeface="Futura" pitchFamily="34" charset="-120"/>
               </a:rPr>
-              <a:t>Core 1 · Fall 2026</a:t>
+              <a:t>Core 1 · Fall 2026 · on Zoom</a:t>
             </a:r>
             <a:endParaRPr lang="en-US" sz="1900" dirty="0"/>
           </a:p>
@@ -4937,6 +4937,45 @@
           </a:p>
         </p:txBody>
       </p:sp>
+      <p:sp>
+        <p:nvSpPr>
+          <p:cNvPr id="90" name="Zoom cue"/>
+          <p:cNvSpPr txBox="1"/>
+          <p:nvPr/>
+        </p:nvSpPr>
+        <p:spPr>
+          <a:xfrm>
+            <a:off x="1028700" y="8778240"/>
+            <a:ext cx="16230600" cy="411480"/>
+          </a:xfrm>
+          <a:prstGeom prst="rect">
+            <a:avLst/>
+          </a:prstGeom>
+          <a:noFill/>
+          <a:ln/>
+        </p:spPr>
+        <p:txBody>
+          <a:bodyPr wrap="square" lIns="0" tIns="0" rIns="0" bIns="0" rtlCol="0" anchor="ctr"/>
+          <a:lstStyle/>
+          <a:p>
+            <a:pPr indent="0" marL="0">
+              <a:buNone/>
+            </a:pPr>
+            <a:r>
+              <a:rPr lang="en-US" sz="1700" i="1" dirty="0">
+                <a:solidFill>
+                  <a:srgbClr val="5A6571"/>
+                </a:solidFill>
+                <a:latin typeface="Futura" pitchFamily="34" charset="0"/>
+                <a:ea typeface="Futura" pitchFamily="34" charset="-122"/>
+                <a:cs typeface="Futura" pitchFamily="34" charset="-120"/>
+              </a:rPr>
+              <a:t>React with a thumbs-up in Zoom after each step. Stuck? Say so in the chat.</a:t>
+            </a:r>
+            <a:endParaRPr lang="en-US" sz="1700" dirty="0"/>
+          </a:p>
+        </p:txBody>
+      </p:sp>
     </p:spTree>
   </p:cSld>
   <p:clrMapOvr>
@@ -7367,7 +7406,7 @@
                 <a:ea typeface="Futura" pitchFamily="34" charset="-122"/>
                 <a:cs typeface="Futura" pitchFamily="34" charset="-120"/>
               </a:rPr>
-              <a:t>Next: Core 2 — Workflow Enhancement. Use Copilot and ChatGPT Edu to speed up the work you already do.</a:t>
+              <a:t>Next: Core 2 — Workflow Enhancement. Start from your own plan, then let AI draft or refine.</a:t>
             </a:r>
             <a:endParaRPr lang="en-US" sz="2600" dirty="0"/>
           </a:p>

</xml_diff>